<commit_message>
pcb first draft finished
</commit_message>
<xml_diff>
--- a/docs/PCB_interfaces.pptx
+++ b/docs/PCB_interfaces.pptx
@@ -6,6 +6,7 @@
   </p:sldMasterIdLst>
   <p:sldIdLst>
     <p:sldId id="257" r:id="rId2"/>
+    <p:sldId id="258" r:id="rId3"/>
   </p:sldIdLst>
   <p:sldSz cx="12192000" cy="6858000"/>
   <p:notesSz cx="6858000" cy="9144000"/>
@@ -259,7 +260,7 @@
           <a:p>
             <a:fld id="{5C26CB86-9D02-4EAF-92D6-993F0AA89364}" type="datetimeFigureOut">
               <a:rPr lang="de-DE" smtClean="0"/>
-              <a:t>23.12.2022</a:t>
+              <a:t>09.01.2023</a:t>
             </a:fld>
             <a:endParaRPr lang="de-DE"/>
           </a:p>
@@ -313,7 +314,7 @@
           <a:p>
             <a:fld id="{95176C13-B2CD-406A-8CCB-6356FE93C9A4}" type="slidenum">
               <a:rPr lang="de-DE" smtClean="0"/>
-              <a:t>‹Nr.›</a:t>
+              <a:t>‹#›</a:t>
             </a:fld>
             <a:endParaRPr lang="de-DE"/>
           </a:p>
@@ -457,7 +458,7 @@
           <a:p>
             <a:fld id="{5C26CB86-9D02-4EAF-92D6-993F0AA89364}" type="datetimeFigureOut">
               <a:rPr lang="de-DE" smtClean="0"/>
-              <a:t>23.12.2022</a:t>
+              <a:t>09.01.2023</a:t>
             </a:fld>
             <a:endParaRPr lang="de-DE"/>
           </a:p>
@@ -511,7 +512,7 @@
           <a:p>
             <a:fld id="{95176C13-B2CD-406A-8CCB-6356FE93C9A4}" type="slidenum">
               <a:rPr lang="de-DE" smtClean="0"/>
-              <a:t>‹Nr.›</a:t>
+              <a:t>‹#›</a:t>
             </a:fld>
             <a:endParaRPr lang="de-DE"/>
           </a:p>
@@ -665,7 +666,7 @@
           <a:p>
             <a:fld id="{5C26CB86-9D02-4EAF-92D6-993F0AA89364}" type="datetimeFigureOut">
               <a:rPr lang="de-DE" smtClean="0"/>
-              <a:t>23.12.2022</a:t>
+              <a:t>09.01.2023</a:t>
             </a:fld>
             <a:endParaRPr lang="de-DE"/>
           </a:p>
@@ -719,7 +720,7 @@
           <a:p>
             <a:fld id="{95176C13-B2CD-406A-8CCB-6356FE93C9A4}" type="slidenum">
               <a:rPr lang="de-DE" smtClean="0"/>
-              <a:t>‹Nr.›</a:t>
+              <a:t>‹#›</a:t>
             </a:fld>
             <a:endParaRPr lang="de-DE"/>
           </a:p>
@@ -863,7 +864,7 @@
           <a:p>
             <a:fld id="{5C26CB86-9D02-4EAF-92D6-993F0AA89364}" type="datetimeFigureOut">
               <a:rPr lang="de-DE" smtClean="0"/>
-              <a:t>23.12.2022</a:t>
+              <a:t>09.01.2023</a:t>
             </a:fld>
             <a:endParaRPr lang="de-DE"/>
           </a:p>
@@ -917,7 +918,7 @@
           <a:p>
             <a:fld id="{95176C13-B2CD-406A-8CCB-6356FE93C9A4}" type="slidenum">
               <a:rPr lang="de-DE" smtClean="0"/>
-              <a:t>‹Nr.›</a:t>
+              <a:t>‹#›</a:t>
             </a:fld>
             <a:endParaRPr lang="de-DE"/>
           </a:p>
@@ -1138,7 +1139,7 @@
           <a:p>
             <a:fld id="{5C26CB86-9D02-4EAF-92D6-993F0AA89364}" type="datetimeFigureOut">
               <a:rPr lang="de-DE" smtClean="0"/>
-              <a:t>23.12.2022</a:t>
+              <a:t>09.01.2023</a:t>
             </a:fld>
             <a:endParaRPr lang="de-DE"/>
           </a:p>
@@ -1192,7 +1193,7 @@
           <a:p>
             <a:fld id="{95176C13-B2CD-406A-8CCB-6356FE93C9A4}" type="slidenum">
               <a:rPr lang="de-DE" smtClean="0"/>
-              <a:t>‹Nr.›</a:t>
+              <a:t>‹#›</a:t>
             </a:fld>
             <a:endParaRPr lang="de-DE"/>
           </a:p>
@@ -1403,7 +1404,7 @@
           <a:p>
             <a:fld id="{5C26CB86-9D02-4EAF-92D6-993F0AA89364}" type="datetimeFigureOut">
               <a:rPr lang="de-DE" smtClean="0"/>
-              <a:t>23.12.2022</a:t>
+              <a:t>09.01.2023</a:t>
             </a:fld>
             <a:endParaRPr lang="de-DE"/>
           </a:p>
@@ -1457,7 +1458,7 @@
           <a:p>
             <a:fld id="{95176C13-B2CD-406A-8CCB-6356FE93C9A4}" type="slidenum">
               <a:rPr lang="de-DE" smtClean="0"/>
-              <a:t>‹Nr.›</a:t>
+              <a:t>‹#›</a:t>
             </a:fld>
             <a:endParaRPr lang="de-DE"/>
           </a:p>
@@ -1815,7 +1816,7 @@
           <a:p>
             <a:fld id="{5C26CB86-9D02-4EAF-92D6-993F0AA89364}" type="datetimeFigureOut">
               <a:rPr lang="de-DE" smtClean="0"/>
-              <a:t>23.12.2022</a:t>
+              <a:t>09.01.2023</a:t>
             </a:fld>
             <a:endParaRPr lang="de-DE"/>
           </a:p>
@@ -1869,7 +1870,7 @@
           <a:p>
             <a:fld id="{95176C13-B2CD-406A-8CCB-6356FE93C9A4}" type="slidenum">
               <a:rPr lang="de-DE" smtClean="0"/>
-              <a:t>‹Nr.›</a:t>
+              <a:t>‹#›</a:t>
             </a:fld>
             <a:endParaRPr lang="de-DE"/>
           </a:p>
@@ -1956,7 +1957,7 @@
           <a:p>
             <a:fld id="{5C26CB86-9D02-4EAF-92D6-993F0AA89364}" type="datetimeFigureOut">
               <a:rPr lang="de-DE" smtClean="0"/>
-              <a:t>23.12.2022</a:t>
+              <a:t>09.01.2023</a:t>
             </a:fld>
             <a:endParaRPr lang="de-DE"/>
           </a:p>
@@ -2010,7 +2011,7 @@
           <a:p>
             <a:fld id="{95176C13-B2CD-406A-8CCB-6356FE93C9A4}" type="slidenum">
               <a:rPr lang="de-DE" smtClean="0"/>
-              <a:t>‹Nr.›</a:t>
+              <a:t>‹#›</a:t>
             </a:fld>
             <a:endParaRPr lang="de-DE"/>
           </a:p>
@@ -2069,7 +2070,7 @@
           <a:p>
             <a:fld id="{5C26CB86-9D02-4EAF-92D6-993F0AA89364}" type="datetimeFigureOut">
               <a:rPr lang="de-DE" smtClean="0"/>
-              <a:t>23.12.2022</a:t>
+              <a:t>09.01.2023</a:t>
             </a:fld>
             <a:endParaRPr lang="de-DE"/>
           </a:p>
@@ -2123,7 +2124,7 @@
           <a:p>
             <a:fld id="{95176C13-B2CD-406A-8CCB-6356FE93C9A4}" type="slidenum">
               <a:rPr lang="de-DE" smtClean="0"/>
-              <a:t>‹Nr.›</a:t>
+              <a:t>‹#›</a:t>
             </a:fld>
             <a:endParaRPr lang="de-DE"/>
           </a:p>
@@ -2380,7 +2381,7 @@
           <a:p>
             <a:fld id="{5C26CB86-9D02-4EAF-92D6-993F0AA89364}" type="datetimeFigureOut">
               <a:rPr lang="de-DE" smtClean="0"/>
-              <a:t>23.12.2022</a:t>
+              <a:t>09.01.2023</a:t>
             </a:fld>
             <a:endParaRPr lang="de-DE"/>
           </a:p>
@@ -2434,7 +2435,7 @@
           <a:p>
             <a:fld id="{95176C13-B2CD-406A-8CCB-6356FE93C9A4}" type="slidenum">
               <a:rPr lang="de-DE" smtClean="0"/>
-              <a:t>‹Nr.›</a:t>
+              <a:t>‹#›</a:t>
             </a:fld>
             <a:endParaRPr lang="de-DE"/>
           </a:p>
@@ -2668,7 +2669,7 @@
           <a:p>
             <a:fld id="{5C26CB86-9D02-4EAF-92D6-993F0AA89364}" type="datetimeFigureOut">
               <a:rPr lang="de-DE" smtClean="0"/>
-              <a:t>23.12.2022</a:t>
+              <a:t>09.01.2023</a:t>
             </a:fld>
             <a:endParaRPr lang="de-DE"/>
           </a:p>
@@ -2722,7 +2723,7 @@
           <a:p>
             <a:fld id="{95176C13-B2CD-406A-8CCB-6356FE93C9A4}" type="slidenum">
               <a:rPr lang="de-DE" smtClean="0"/>
-              <a:t>‹Nr.›</a:t>
+              <a:t>‹#›</a:t>
             </a:fld>
             <a:endParaRPr lang="de-DE"/>
           </a:p>
@@ -2909,7 +2910,7 @@
           <a:p>
             <a:fld id="{5C26CB86-9D02-4EAF-92D6-993F0AA89364}" type="datetimeFigureOut">
               <a:rPr lang="de-DE" smtClean="0"/>
-              <a:t>23.12.2022</a:t>
+              <a:t>09.01.2023</a:t>
             </a:fld>
             <a:endParaRPr lang="de-DE"/>
           </a:p>
@@ -2999,7 +3000,7 @@
           <a:p>
             <a:fld id="{95176C13-B2CD-406A-8CCB-6356FE93C9A4}" type="slidenum">
               <a:rPr lang="de-DE" smtClean="0"/>
-              <a:t>‹Nr.›</a:t>
+              <a:t>‹#›</a:t>
             </a:fld>
             <a:endParaRPr lang="de-DE"/>
           </a:p>
@@ -4599,6 +4600,1820 @@
 </p:sld>
 </file>
 
+<file path=ppt/slides/slide2.xml><?xml version="1.0" encoding="utf-8"?>
+<p:sld xmlns:a="http://schemas.openxmlformats.org/drawingml/2006/main" xmlns:r="http://schemas.openxmlformats.org/officeDocument/2006/relationships" xmlns:p="http://schemas.openxmlformats.org/presentationml/2006/main">
+  <p:cSld>
+    <p:spTree>
+      <p:nvGrpSpPr>
+        <p:cNvPr id="1" name=""/>
+        <p:cNvGrpSpPr/>
+        <p:nvPr/>
+      </p:nvGrpSpPr>
+      <p:grpSpPr>
+        <a:xfrm>
+          <a:off x="0" y="0"/>
+          <a:ext cx="0" cy="0"/>
+          <a:chOff x="0" y="0"/>
+          <a:chExt cx="0" cy="0"/>
+        </a:xfrm>
+      </p:grpSpPr>
+      <p:sp>
+        <p:nvSpPr>
+          <p:cNvPr id="32" name="Rechteck 31">
+            <a:extLst>
+              <a:ext uri="{FF2B5EF4-FFF2-40B4-BE49-F238E27FC236}">
+                <a16:creationId xmlns:a16="http://schemas.microsoft.com/office/drawing/2014/main" id="{D4F3BB8A-F71F-4A3E-F657-754EC67A9597}"/>
+              </a:ext>
+            </a:extLst>
+          </p:cNvPr>
+          <p:cNvSpPr/>
+          <p:nvPr/>
+        </p:nvSpPr>
+        <p:spPr>
+          <a:xfrm>
+            <a:off x="4721655" y="2951333"/>
+            <a:ext cx="473018" cy="816859"/>
+          </a:xfrm>
+          <a:prstGeom prst="rect">
+            <a:avLst/>
+          </a:prstGeom>
+          <a:solidFill>
+            <a:schemeClr val="bg1"/>
+          </a:solidFill>
+        </p:spPr>
+        <p:style>
+          <a:lnRef idx="2">
+            <a:schemeClr val="accent6">
+              <a:shade val="50000"/>
+            </a:schemeClr>
+          </a:lnRef>
+          <a:fillRef idx="1">
+            <a:schemeClr val="accent6"/>
+          </a:fillRef>
+          <a:effectRef idx="0">
+            <a:schemeClr val="accent6"/>
+          </a:effectRef>
+          <a:fontRef idx="minor">
+            <a:schemeClr val="lt1"/>
+          </a:fontRef>
+        </p:style>
+        <p:txBody>
+          <a:bodyPr rtlCol="0" anchor="ctr"/>
+          <a:lstStyle/>
+          <a:p>
+            <a:pPr marL="0" marR="0" lvl="0" indent="0" algn="ctr" defTabSz="914400" rtl="0" eaLnBrk="1" fontAlgn="auto" latinLnBrk="0" hangingPunct="1">
+              <a:lnSpc>
+                <a:spcPct val="100000"/>
+              </a:lnSpc>
+              <a:spcBef>
+                <a:spcPts val="0"/>
+              </a:spcBef>
+              <a:spcAft>
+                <a:spcPts val="0"/>
+              </a:spcAft>
+              <a:buClrTx/>
+              <a:buSzTx/>
+              <a:buFontTx/>
+              <a:buNone/>
+              <a:tabLst/>
+              <a:defRPr/>
+            </a:pPr>
+            <a:endParaRPr kumimoji="0" lang="de-DE" sz="1800" b="0" i="0" u="none" strike="noStrike" kern="1200" cap="none" spc="0" normalizeH="0" baseline="0" noProof="0">
+              <a:ln>
+                <a:noFill/>
+              </a:ln>
+              <a:solidFill>
+                <a:prstClr val="white"/>
+              </a:solidFill>
+              <a:effectLst/>
+              <a:uLnTx/>
+              <a:uFillTx/>
+              <a:latin typeface="Calibri" panose="020F0502020204030204"/>
+              <a:ea typeface="+mn-ea"/>
+              <a:cs typeface="+mn-cs"/>
+            </a:endParaRPr>
+          </a:p>
+        </p:txBody>
+      </p:sp>
+      <p:sp>
+        <p:nvSpPr>
+          <p:cNvPr id="37" name="Textfeld 36">
+            <a:extLst>
+              <a:ext uri="{FF2B5EF4-FFF2-40B4-BE49-F238E27FC236}">
+                <a16:creationId xmlns:a16="http://schemas.microsoft.com/office/drawing/2014/main" id="{F844ECC7-9088-00B0-2632-AD21D30468AC}"/>
+              </a:ext>
+            </a:extLst>
+          </p:cNvPr>
+          <p:cNvSpPr txBox="1"/>
+          <p:nvPr/>
+        </p:nvSpPr>
+        <p:spPr>
+          <a:xfrm rot="16200000">
+            <a:off x="4424199" y="3175095"/>
+            <a:ext cx="1112811" cy="369332"/>
+          </a:xfrm>
+          <a:prstGeom prst="rect">
+            <a:avLst/>
+          </a:prstGeom>
+          <a:noFill/>
+        </p:spPr>
+        <p:txBody>
+          <a:bodyPr wrap="square" rtlCol="0">
+            <a:spAutoFit/>
+          </a:bodyPr>
+          <a:lstStyle/>
+          <a:p>
+            <a:pPr marL="0" marR="0" lvl="0" indent="0" algn="ctr" defTabSz="914400" rtl="0" eaLnBrk="1" fontAlgn="auto" latinLnBrk="0" hangingPunct="1">
+              <a:lnSpc>
+                <a:spcPct val="100000"/>
+              </a:lnSpc>
+              <a:spcBef>
+                <a:spcPts val="0"/>
+              </a:spcBef>
+              <a:spcAft>
+                <a:spcPts val="0"/>
+              </a:spcAft>
+              <a:buClrTx/>
+              <a:buSzTx/>
+              <a:buFontTx/>
+              <a:buNone/>
+              <a:tabLst/>
+              <a:defRPr/>
+            </a:pPr>
+            <a:r>
+              <a:rPr kumimoji="0" lang="de-DE" sz="1800" b="0" i="0" u="none" strike="noStrike" kern="1200" cap="none" spc="0" normalizeH="0" baseline="0" noProof="0" dirty="0">
+                <a:ln>
+                  <a:noFill/>
+                </a:ln>
+                <a:solidFill>
+                  <a:prstClr val="black"/>
+                </a:solidFill>
+                <a:effectLst/>
+                <a:uLnTx/>
+                <a:uFillTx/>
+                <a:latin typeface="Calibri" panose="020F0502020204030204"/>
+                <a:ea typeface="+mn-ea"/>
+                <a:cs typeface="+mn-cs"/>
+              </a:rPr>
+              <a:t>IPM</a:t>
+            </a:r>
+          </a:p>
+        </p:txBody>
+      </p:sp>
+      <p:sp>
+        <p:nvSpPr>
+          <p:cNvPr id="38" name="Oval 37">
+            <a:extLst>
+              <a:ext uri="{FF2B5EF4-FFF2-40B4-BE49-F238E27FC236}">
+                <a16:creationId xmlns:a16="http://schemas.microsoft.com/office/drawing/2014/main" id="{2A58F107-28D6-1000-A02B-A81C26EEA41B}"/>
+              </a:ext>
+            </a:extLst>
+          </p:cNvPr>
+          <p:cNvSpPr/>
+          <p:nvPr/>
+        </p:nvSpPr>
+        <p:spPr>
+          <a:xfrm>
+            <a:off x="2150397" y="3797639"/>
+            <a:ext cx="388452" cy="369330"/>
+          </a:xfrm>
+          <a:prstGeom prst="ellipse">
+            <a:avLst/>
+          </a:prstGeom>
+          <a:noFill/>
+          <a:ln>
+            <a:solidFill>
+              <a:schemeClr val="tx1"/>
+            </a:solidFill>
+          </a:ln>
+        </p:spPr>
+        <p:style>
+          <a:lnRef idx="2">
+            <a:schemeClr val="accent1">
+              <a:shade val="50000"/>
+            </a:schemeClr>
+          </a:lnRef>
+          <a:fillRef idx="1">
+            <a:schemeClr val="accent1"/>
+          </a:fillRef>
+          <a:effectRef idx="0">
+            <a:schemeClr val="accent1"/>
+          </a:effectRef>
+          <a:fontRef idx="minor">
+            <a:schemeClr val="lt1"/>
+          </a:fontRef>
+        </p:style>
+        <p:txBody>
+          <a:bodyPr rtlCol="0" anchor="ctr"/>
+          <a:lstStyle/>
+          <a:p>
+            <a:pPr algn="ctr"/>
+            <a:endParaRPr lang="en-GB" dirty="0"/>
+          </a:p>
+        </p:txBody>
+      </p:sp>
+      <p:cxnSp>
+        <p:nvCxnSpPr>
+          <p:cNvPr id="40" name="Straight Connector 39">
+            <a:extLst>
+              <a:ext uri="{FF2B5EF4-FFF2-40B4-BE49-F238E27FC236}">
+                <a16:creationId xmlns:a16="http://schemas.microsoft.com/office/drawing/2014/main" id="{80BFDE87-6887-E799-A520-0F7E28525DAE}"/>
+              </a:ext>
+            </a:extLst>
+          </p:cNvPr>
+          <p:cNvCxnSpPr>
+            <a:stCxn id="38" idx="1"/>
+            <a:endCxn id="38" idx="5"/>
+          </p:cNvCxnSpPr>
+          <p:nvPr/>
+        </p:nvCxnSpPr>
+        <p:spPr>
+          <a:xfrm>
+            <a:off x="2207284" y="3851726"/>
+            <a:ext cx="274678" cy="261156"/>
+          </a:xfrm>
+          <a:prstGeom prst="line">
+            <a:avLst/>
+          </a:prstGeom>
+          <a:ln>
+            <a:solidFill>
+              <a:schemeClr val="tx1"/>
+            </a:solidFill>
+          </a:ln>
+        </p:spPr>
+        <p:style>
+          <a:lnRef idx="1">
+            <a:schemeClr val="accent1"/>
+          </a:lnRef>
+          <a:fillRef idx="0">
+            <a:schemeClr val="accent1"/>
+          </a:fillRef>
+          <a:effectRef idx="0">
+            <a:schemeClr val="accent1"/>
+          </a:effectRef>
+          <a:fontRef idx="minor">
+            <a:schemeClr val="tx1"/>
+          </a:fontRef>
+        </p:style>
+      </p:cxnSp>
+      <p:cxnSp>
+        <p:nvCxnSpPr>
+          <p:cNvPr id="42" name="Straight Connector 41">
+            <a:extLst>
+              <a:ext uri="{FF2B5EF4-FFF2-40B4-BE49-F238E27FC236}">
+                <a16:creationId xmlns:a16="http://schemas.microsoft.com/office/drawing/2014/main" id="{ED8B627E-5C1F-97E1-8A5A-BAA5DAAD0A14}"/>
+              </a:ext>
+            </a:extLst>
+          </p:cNvPr>
+          <p:cNvCxnSpPr>
+            <a:stCxn id="38" idx="3"/>
+            <a:endCxn id="38" idx="7"/>
+          </p:cNvCxnSpPr>
+          <p:nvPr/>
+        </p:nvCxnSpPr>
+        <p:spPr>
+          <a:xfrm flipV="1">
+            <a:off x="2207284" y="3851726"/>
+            <a:ext cx="274678" cy="261156"/>
+          </a:xfrm>
+          <a:prstGeom prst="line">
+            <a:avLst/>
+          </a:prstGeom>
+          <a:ln>
+            <a:solidFill>
+              <a:schemeClr val="tx1"/>
+            </a:solidFill>
+          </a:ln>
+        </p:spPr>
+        <p:style>
+          <a:lnRef idx="1">
+            <a:schemeClr val="accent1"/>
+          </a:lnRef>
+          <a:fillRef idx="0">
+            <a:schemeClr val="accent1"/>
+          </a:fillRef>
+          <a:effectRef idx="0">
+            <a:schemeClr val="accent1"/>
+          </a:effectRef>
+          <a:fontRef idx="minor">
+            <a:schemeClr val="tx1"/>
+          </a:fontRef>
+        </p:style>
+      </p:cxnSp>
+      <p:sp>
+        <p:nvSpPr>
+          <p:cNvPr id="43" name="Oval 42">
+            <a:extLst>
+              <a:ext uri="{FF2B5EF4-FFF2-40B4-BE49-F238E27FC236}">
+                <a16:creationId xmlns:a16="http://schemas.microsoft.com/office/drawing/2014/main" id="{BFA9F97F-C5F3-F875-541B-03C1CB03B122}"/>
+              </a:ext>
+            </a:extLst>
+          </p:cNvPr>
+          <p:cNvSpPr/>
+          <p:nvPr/>
+        </p:nvSpPr>
+        <p:spPr>
+          <a:xfrm>
+            <a:off x="3210048" y="2553599"/>
+            <a:ext cx="388452" cy="369330"/>
+          </a:xfrm>
+          <a:prstGeom prst="ellipse">
+            <a:avLst/>
+          </a:prstGeom>
+          <a:noFill/>
+          <a:ln>
+            <a:solidFill>
+              <a:schemeClr val="tx1"/>
+            </a:solidFill>
+          </a:ln>
+        </p:spPr>
+        <p:style>
+          <a:lnRef idx="2">
+            <a:schemeClr val="accent1">
+              <a:shade val="50000"/>
+            </a:schemeClr>
+          </a:lnRef>
+          <a:fillRef idx="1">
+            <a:schemeClr val="accent1"/>
+          </a:fillRef>
+          <a:effectRef idx="0">
+            <a:schemeClr val="accent1"/>
+          </a:effectRef>
+          <a:fontRef idx="minor">
+            <a:schemeClr val="lt1"/>
+          </a:fontRef>
+        </p:style>
+        <p:txBody>
+          <a:bodyPr rtlCol="0" anchor="ctr"/>
+          <a:lstStyle/>
+          <a:p>
+            <a:pPr algn="ctr"/>
+            <a:endParaRPr lang="en-GB" dirty="0"/>
+          </a:p>
+        </p:txBody>
+      </p:sp>
+      <p:cxnSp>
+        <p:nvCxnSpPr>
+          <p:cNvPr id="44" name="Straight Connector 43">
+            <a:extLst>
+              <a:ext uri="{FF2B5EF4-FFF2-40B4-BE49-F238E27FC236}">
+                <a16:creationId xmlns:a16="http://schemas.microsoft.com/office/drawing/2014/main" id="{F5A65FB5-AC88-5BA8-C4AD-BF5961598EBE}"/>
+              </a:ext>
+            </a:extLst>
+          </p:cNvPr>
+          <p:cNvCxnSpPr>
+            <a:stCxn id="43" idx="1"/>
+            <a:endCxn id="43" idx="5"/>
+          </p:cNvCxnSpPr>
+          <p:nvPr/>
+        </p:nvCxnSpPr>
+        <p:spPr>
+          <a:xfrm>
+            <a:off x="3266935" y="2607686"/>
+            <a:ext cx="274678" cy="261156"/>
+          </a:xfrm>
+          <a:prstGeom prst="line">
+            <a:avLst/>
+          </a:prstGeom>
+          <a:ln>
+            <a:solidFill>
+              <a:schemeClr val="tx1"/>
+            </a:solidFill>
+          </a:ln>
+        </p:spPr>
+        <p:style>
+          <a:lnRef idx="1">
+            <a:schemeClr val="accent1"/>
+          </a:lnRef>
+          <a:fillRef idx="0">
+            <a:schemeClr val="accent1"/>
+          </a:fillRef>
+          <a:effectRef idx="0">
+            <a:schemeClr val="accent1"/>
+          </a:effectRef>
+          <a:fontRef idx="minor">
+            <a:schemeClr val="tx1"/>
+          </a:fontRef>
+        </p:style>
+      </p:cxnSp>
+      <p:cxnSp>
+        <p:nvCxnSpPr>
+          <p:cNvPr id="45" name="Straight Connector 44">
+            <a:extLst>
+              <a:ext uri="{FF2B5EF4-FFF2-40B4-BE49-F238E27FC236}">
+                <a16:creationId xmlns:a16="http://schemas.microsoft.com/office/drawing/2014/main" id="{FCDF0B27-3A02-4133-DE86-00A7A6ADB178}"/>
+              </a:ext>
+            </a:extLst>
+          </p:cNvPr>
+          <p:cNvCxnSpPr>
+            <a:stCxn id="43" idx="3"/>
+            <a:endCxn id="43" idx="7"/>
+          </p:cNvCxnSpPr>
+          <p:nvPr/>
+        </p:nvCxnSpPr>
+        <p:spPr>
+          <a:xfrm flipV="1">
+            <a:off x="3266935" y="2607686"/>
+            <a:ext cx="274678" cy="261156"/>
+          </a:xfrm>
+          <a:prstGeom prst="line">
+            <a:avLst/>
+          </a:prstGeom>
+          <a:ln>
+            <a:solidFill>
+              <a:schemeClr val="tx1"/>
+            </a:solidFill>
+          </a:ln>
+        </p:spPr>
+        <p:style>
+          <a:lnRef idx="1">
+            <a:schemeClr val="accent1"/>
+          </a:lnRef>
+          <a:fillRef idx="0">
+            <a:schemeClr val="accent1"/>
+          </a:fillRef>
+          <a:effectRef idx="0">
+            <a:schemeClr val="accent1"/>
+          </a:effectRef>
+          <a:fontRef idx="minor">
+            <a:schemeClr val="tx1"/>
+          </a:fontRef>
+        </p:style>
+      </p:cxnSp>
+      <p:sp>
+        <p:nvSpPr>
+          <p:cNvPr id="46" name="Oval 45">
+            <a:extLst>
+              <a:ext uri="{FF2B5EF4-FFF2-40B4-BE49-F238E27FC236}">
+                <a16:creationId xmlns:a16="http://schemas.microsoft.com/office/drawing/2014/main" id="{A10E1A9B-FBE6-9ED8-BE85-6EDAA14A1967}"/>
+              </a:ext>
+            </a:extLst>
+          </p:cNvPr>
+          <p:cNvSpPr/>
+          <p:nvPr/>
+        </p:nvSpPr>
+        <p:spPr>
+          <a:xfrm>
+            <a:off x="6415616" y="3797639"/>
+            <a:ext cx="388452" cy="369330"/>
+          </a:xfrm>
+          <a:prstGeom prst="ellipse">
+            <a:avLst/>
+          </a:prstGeom>
+          <a:noFill/>
+          <a:ln>
+            <a:solidFill>
+              <a:schemeClr val="tx1"/>
+            </a:solidFill>
+          </a:ln>
+        </p:spPr>
+        <p:style>
+          <a:lnRef idx="2">
+            <a:schemeClr val="accent1">
+              <a:shade val="50000"/>
+            </a:schemeClr>
+          </a:lnRef>
+          <a:fillRef idx="1">
+            <a:schemeClr val="accent1"/>
+          </a:fillRef>
+          <a:effectRef idx="0">
+            <a:schemeClr val="accent1"/>
+          </a:effectRef>
+          <a:fontRef idx="minor">
+            <a:schemeClr val="lt1"/>
+          </a:fontRef>
+        </p:style>
+        <p:txBody>
+          <a:bodyPr rtlCol="0" anchor="ctr"/>
+          <a:lstStyle/>
+          <a:p>
+            <a:pPr algn="ctr"/>
+            <a:endParaRPr lang="en-GB" dirty="0"/>
+          </a:p>
+        </p:txBody>
+      </p:sp>
+      <p:cxnSp>
+        <p:nvCxnSpPr>
+          <p:cNvPr id="47" name="Straight Connector 46">
+            <a:extLst>
+              <a:ext uri="{FF2B5EF4-FFF2-40B4-BE49-F238E27FC236}">
+                <a16:creationId xmlns:a16="http://schemas.microsoft.com/office/drawing/2014/main" id="{91884E11-4B78-5654-D805-016ACBDC057E}"/>
+              </a:ext>
+            </a:extLst>
+          </p:cNvPr>
+          <p:cNvCxnSpPr>
+            <a:stCxn id="46" idx="1"/>
+            <a:endCxn id="46" idx="5"/>
+          </p:cNvCxnSpPr>
+          <p:nvPr/>
+        </p:nvCxnSpPr>
+        <p:spPr>
+          <a:xfrm>
+            <a:off x="6472503" y="3851726"/>
+            <a:ext cx="274678" cy="261156"/>
+          </a:xfrm>
+          <a:prstGeom prst="line">
+            <a:avLst/>
+          </a:prstGeom>
+          <a:ln>
+            <a:solidFill>
+              <a:schemeClr val="tx1"/>
+            </a:solidFill>
+          </a:ln>
+        </p:spPr>
+        <p:style>
+          <a:lnRef idx="1">
+            <a:schemeClr val="accent1"/>
+          </a:lnRef>
+          <a:fillRef idx="0">
+            <a:schemeClr val="accent1"/>
+          </a:fillRef>
+          <a:effectRef idx="0">
+            <a:schemeClr val="accent1"/>
+          </a:effectRef>
+          <a:fontRef idx="minor">
+            <a:schemeClr val="tx1"/>
+          </a:fontRef>
+        </p:style>
+      </p:cxnSp>
+      <p:cxnSp>
+        <p:nvCxnSpPr>
+          <p:cNvPr id="48" name="Straight Connector 47">
+            <a:extLst>
+              <a:ext uri="{FF2B5EF4-FFF2-40B4-BE49-F238E27FC236}">
+                <a16:creationId xmlns:a16="http://schemas.microsoft.com/office/drawing/2014/main" id="{D6854E16-6F44-3636-2328-C4EC433173CF}"/>
+              </a:ext>
+            </a:extLst>
+          </p:cNvPr>
+          <p:cNvCxnSpPr>
+            <a:stCxn id="46" idx="3"/>
+            <a:endCxn id="46" idx="7"/>
+          </p:cNvCxnSpPr>
+          <p:nvPr/>
+        </p:nvCxnSpPr>
+        <p:spPr>
+          <a:xfrm flipV="1">
+            <a:off x="6472503" y="3851726"/>
+            <a:ext cx="274678" cy="261156"/>
+          </a:xfrm>
+          <a:prstGeom prst="line">
+            <a:avLst/>
+          </a:prstGeom>
+          <a:ln>
+            <a:solidFill>
+              <a:schemeClr val="tx1"/>
+            </a:solidFill>
+          </a:ln>
+        </p:spPr>
+        <p:style>
+          <a:lnRef idx="1">
+            <a:schemeClr val="accent1"/>
+          </a:lnRef>
+          <a:fillRef idx="0">
+            <a:schemeClr val="accent1"/>
+          </a:fillRef>
+          <a:effectRef idx="0">
+            <a:schemeClr val="accent1"/>
+          </a:effectRef>
+          <a:fontRef idx="minor">
+            <a:schemeClr val="tx1"/>
+          </a:fontRef>
+        </p:style>
+      </p:cxnSp>
+      <p:sp>
+        <p:nvSpPr>
+          <p:cNvPr id="49" name="Oval 48">
+            <a:extLst>
+              <a:ext uri="{FF2B5EF4-FFF2-40B4-BE49-F238E27FC236}">
+                <a16:creationId xmlns:a16="http://schemas.microsoft.com/office/drawing/2014/main" id="{B400D403-B100-9751-8954-A0D0E5FE8F4E}"/>
+              </a:ext>
+            </a:extLst>
+          </p:cNvPr>
+          <p:cNvSpPr/>
+          <p:nvPr/>
+        </p:nvSpPr>
+        <p:spPr>
+          <a:xfrm>
+            <a:off x="5080149" y="1651775"/>
+            <a:ext cx="388452" cy="369330"/>
+          </a:xfrm>
+          <a:prstGeom prst="ellipse">
+            <a:avLst/>
+          </a:prstGeom>
+          <a:noFill/>
+          <a:ln>
+            <a:solidFill>
+              <a:schemeClr val="tx1"/>
+            </a:solidFill>
+          </a:ln>
+        </p:spPr>
+        <p:style>
+          <a:lnRef idx="2">
+            <a:schemeClr val="accent1">
+              <a:shade val="50000"/>
+            </a:schemeClr>
+          </a:lnRef>
+          <a:fillRef idx="1">
+            <a:schemeClr val="accent1"/>
+          </a:fillRef>
+          <a:effectRef idx="0">
+            <a:schemeClr val="accent1"/>
+          </a:effectRef>
+          <a:fontRef idx="minor">
+            <a:schemeClr val="lt1"/>
+          </a:fontRef>
+        </p:style>
+        <p:txBody>
+          <a:bodyPr rtlCol="0" anchor="ctr"/>
+          <a:lstStyle/>
+          <a:p>
+            <a:pPr algn="ctr"/>
+            <a:endParaRPr lang="en-GB" dirty="0"/>
+          </a:p>
+        </p:txBody>
+      </p:sp>
+      <p:cxnSp>
+        <p:nvCxnSpPr>
+          <p:cNvPr id="50" name="Straight Connector 49">
+            <a:extLst>
+              <a:ext uri="{FF2B5EF4-FFF2-40B4-BE49-F238E27FC236}">
+                <a16:creationId xmlns:a16="http://schemas.microsoft.com/office/drawing/2014/main" id="{A3D776B4-BB1E-3A76-78B7-FE2E4BDCB5E3}"/>
+              </a:ext>
+            </a:extLst>
+          </p:cNvPr>
+          <p:cNvCxnSpPr>
+            <a:stCxn id="49" idx="1"/>
+            <a:endCxn id="49" idx="5"/>
+          </p:cNvCxnSpPr>
+          <p:nvPr/>
+        </p:nvCxnSpPr>
+        <p:spPr>
+          <a:xfrm>
+            <a:off x="5137036" y="1705862"/>
+            <a:ext cx="274678" cy="261156"/>
+          </a:xfrm>
+          <a:prstGeom prst="line">
+            <a:avLst/>
+          </a:prstGeom>
+          <a:ln>
+            <a:solidFill>
+              <a:schemeClr val="tx1"/>
+            </a:solidFill>
+          </a:ln>
+        </p:spPr>
+        <p:style>
+          <a:lnRef idx="1">
+            <a:schemeClr val="accent1"/>
+          </a:lnRef>
+          <a:fillRef idx="0">
+            <a:schemeClr val="accent1"/>
+          </a:fillRef>
+          <a:effectRef idx="0">
+            <a:schemeClr val="accent1"/>
+          </a:effectRef>
+          <a:fontRef idx="minor">
+            <a:schemeClr val="tx1"/>
+          </a:fontRef>
+        </p:style>
+      </p:cxnSp>
+      <p:cxnSp>
+        <p:nvCxnSpPr>
+          <p:cNvPr id="51" name="Straight Connector 50">
+            <a:extLst>
+              <a:ext uri="{FF2B5EF4-FFF2-40B4-BE49-F238E27FC236}">
+                <a16:creationId xmlns:a16="http://schemas.microsoft.com/office/drawing/2014/main" id="{51E4E278-E963-44EA-6FB4-FA5E32683849}"/>
+              </a:ext>
+            </a:extLst>
+          </p:cNvPr>
+          <p:cNvCxnSpPr>
+            <a:cxnSpLocks/>
+            <a:stCxn id="49" idx="3"/>
+            <a:endCxn id="49" idx="7"/>
+          </p:cNvCxnSpPr>
+          <p:nvPr/>
+        </p:nvCxnSpPr>
+        <p:spPr>
+          <a:xfrm flipV="1">
+            <a:off x="5137036" y="1705862"/>
+            <a:ext cx="274678" cy="261156"/>
+          </a:xfrm>
+          <a:prstGeom prst="line">
+            <a:avLst/>
+          </a:prstGeom>
+          <a:ln>
+            <a:solidFill>
+              <a:schemeClr val="tx1"/>
+            </a:solidFill>
+          </a:ln>
+        </p:spPr>
+        <p:style>
+          <a:lnRef idx="1">
+            <a:schemeClr val="accent1"/>
+          </a:lnRef>
+          <a:fillRef idx="0">
+            <a:schemeClr val="accent1"/>
+          </a:fillRef>
+          <a:effectRef idx="0">
+            <a:schemeClr val="accent1"/>
+          </a:effectRef>
+          <a:fontRef idx="minor">
+            <a:schemeClr val="tx1"/>
+          </a:fontRef>
+        </p:style>
+      </p:cxnSp>
+      <p:cxnSp>
+        <p:nvCxnSpPr>
+          <p:cNvPr id="52" name="Gerade Verbindung mit Pfeil 1">
+            <a:extLst>
+              <a:ext uri="{FF2B5EF4-FFF2-40B4-BE49-F238E27FC236}">
+                <a16:creationId xmlns:a16="http://schemas.microsoft.com/office/drawing/2014/main" id="{FF93F02D-F8FD-3240-E5D2-C9E0599C8281}"/>
+              </a:ext>
+            </a:extLst>
+          </p:cNvPr>
+          <p:cNvCxnSpPr>
+            <a:cxnSpLocks/>
+          </p:cNvCxnSpPr>
+          <p:nvPr/>
+        </p:nvCxnSpPr>
+        <p:spPr>
+          <a:xfrm>
+            <a:off x="3434229" y="2948285"/>
+            <a:ext cx="1473051" cy="3048"/>
+          </a:xfrm>
+          <a:prstGeom prst="straightConnector1">
+            <a:avLst/>
+          </a:prstGeom>
+          <a:ln>
+            <a:solidFill>
+              <a:schemeClr val="tx1"/>
+            </a:solidFill>
+            <a:headEnd type="triangle"/>
+            <a:tailEnd type="triangle"/>
+          </a:ln>
+        </p:spPr>
+        <p:style>
+          <a:lnRef idx="1">
+            <a:schemeClr val="accent1"/>
+          </a:lnRef>
+          <a:fillRef idx="0">
+            <a:schemeClr val="accent1"/>
+          </a:fillRef>
+          <a:effectRef idx="0">
+            <a:schemeClr val="accent1"/>
+          </a:effectRef>
+          <a:fontRef idx="minor">
+            <a:schemeClr val="tx1"/>
+          </a:fontRef>
+        </p:style>
+      </p:cxnSp>
+      <p:cxnSp>
+        <p:nvCxnSpPr>
+          <p:cNvPr id="55" name="Gerade Verbindung mit Pfeil 1">
+            <a:extLst>
+              <a:ext uri="{FF2B5EF4-FFF2-40B4-BE49-F238E27FC236}">
+                <a16:creationId xmlns:a16="http://schemas.microsoft.com/office/drawing/2014/main" id="{C5069DEE-D624-E83C-3C41-84F215401D17}"/>
+              </a:ext>
+            </a:extLst>
+          </p:cNvPr>
+          <p:cNvCxnSpPr>
+            <a:cxnSpLocks/>
+          </p:cNvCxnSpPr>
+          <p:nvPr/>
+        </p:nvCxnSpPr>
+        <p:spPr>
+          <a:xfrm>
+            <a:off x="4975178" y="2334342"/>
+            <a:ext cx="228973" cy="10500"/>
+          </a:xfrm>
+          <a:prstGeom prst="straightConnector1">
+            <a:avLst/>
+          </a:prstGeom>
+          <a:ln>
+            <a:solidFill>
+              <a:schemeClr val="tx1"/>
+            </a:solidFill>
+            <a:headEnd type="triangle"/>
+            <a:tailEnd type="triangle"/>
+          </a:ln>
+        </p:spPr>
+        <p:style>
+          <a:lnRef idx="1">
+            <a:schemeClr val="accent1"/>
+          </a:lnRef>
+          <a:fillRef idx="0">
+            <a:schemeClr val="accent1"/>
+          </a:fillRef>
+          <a:effectRef idx="0">
+            <a:schemeClr val="accent1"/>
+          </a:effectRef>
+          <a:fontRef idx="minor">
+            <a:schemeClr val="tx1"/>
+          </a:fontRef>
+        </p:style>
+      </p:cxnSp>
+      <p:cxnSp>
+        <p:nvCxnSpPr>
+          <p:cNvPr id="65" name="Gerade Verbindung mit Pfeil 7">
+            <a:extLst>
+              <a:ext uri="{FF2B5EF4-FFF2-40B4-BE49-F238E27FC236}">
+                <a16:creationId xmlns:a16="http://schemas.microsoft.com/office/drawing/2014/main" id="{D93D847F-8921-45BD-4629-014F83F6E4E8}"/>
+              </a:ext>
+            </a:extLst>
+          </p:cNvPr>
+          <p:cNvCxnSpPr>
+            <a:cxnSpLocks/>
+          </p:cNvCxnSpPr>
+          <p:nvPr/>
+        </p:nvCxnSpPr>
+        <p:spPr>
+          <a:xfrm flipH="1">
+            <a:off x="5009054" y="3978584"/>
+            <a:ext cx="1525096" cy="0"/>
+          </a:xfrm>
+          <a:prstGeom prst="straightConnector1">
+            <a:avLst/>
+          </a:prstGeom>
+          <a:ln>
+            <a:solidFill>
+              <a:schemeClr val="tx1"/>
+            </a:solidFill>
+            <a:headEnd type="triangle"/>
+            <a:tailEnd type="triangle"/>
+          </a:ln>
+        </p:spPr>
+        <p:style>
+          <a:lnRef idx="1">
+            <a:schemeClr val="accent1"/>
+          </a:lnRef>
+          <a:fillRef idx="0">
+            <a:schemeClr val="accent1"/>
+          </a:fillRef>
+          <a:effectRef idx="0">
+            <a:schemeClr val="accent1"/>
+          </a:effectRef>
+          <a:fontRef idx="minor">
+            <a:schemeClr val="tx1"/>
+          </a:fontRef>
+        </p:style>
+      </p:cxnSp>
+      <p:cxnSp>
+        <p:nvCxnSpPr>
+          <p:cNvPr id="68" name="Gerade Verbindung mit Pfeil 7">
+            <a:extLst>
+              <a:ext uri="{FF2B5EF4-FFF2-40B4-BE49-F238E27FC236}">
+                <a16:creationId xmlns:a16="http://schemas.microsoft.com/office/drawing/2014/main" id="{51C76E73-E726-2D39-D471-26A80BE01062}"/>
+              </a:ext>
+            </a:extLst>
+          </p:cNvPr>
+          <p:cNvCxnSpPr>
+            <a:cxnSpLocks/>
+          </p:cNvCxnSpPr>
+          <p:nvPr/>
+        </p:nvCxnSpPr>
+        <p:spPr>
+          <a:xfrm flipV="1">
+            <a:off x="4965700" y="1762261"/>
+            <a:ext cx="0" cy="794395"/>
+          </a:xfrm>
+          <a:prstGeom prst="straightConnector1">
+            <a:avLst/>
+          </a:prstGeom>
+          <a:ln>
+            <a:solidFill>
+              <a:schemeClr val="tx1"/>
+            </a:solidFill>
+            <a:headEnd type="triangle"/>
+            <a:tailEnd type="triangle"/>
+          </a:ln>
+        </p:spPr>
+        <p:style>
+          <a:lnRef idx="1">
+            <a:schemeClr val="accent1"/>
+          </a:lnRef>
+          <a:fillRef idx="0">
+            <a:schemeClr val="accent1"/>
+          </a:fillRef>
+          <a:effectRef idx="0">
+            <a:schemeClr val="accent1"/>
+          </a:effectRef>
+          <a:fontRef idx="minor">
+            <a:schemeClr val="tx1"/>
+          </a:fontRef>
+        </p:style>
+      </p:cxnSp>
+      <p:sp>
+        <p:nvSpPr>
+          <p:cNvPr id="69" name="Textfeld 25">
+            <a:extLst>
+              <a:ext uri="{FF2B5EF4-FFF2-40B4-BE49-F238E27FC236}">
+                <a16:creationId xmlns:a16="http://schemas.microsoft.com/office/drawing/2014/main" id="{5419F6C9-1734-53CC-3395-4AA587F01E98}"/>
+              </a:ext>
+            </a:extLst>
+          </p:cNvPr>
+          <p:cNvSpPr txBox="1"/>
+          <p:nvPr/>
+        </p:nvSpPr>
+        <p:spPr>
+          <a:xfrm>
+            <a:off x="3241326" y="2998086"/>
+            <a:ext cx="1367278" cy="369332"/>
+          </a:xfrm>
+          <a:prstGeom prst="rect">
+            <a:avLst/>
+          </a:prstGeom>
+          <a:noFill/>
+        </p:spPr>
+        <p:txBody>
+          <a:bodyPr wrap="square" rtlCol="0">
+            <a:spAutoFit/>
+          </a:bodyPr>
+          <a:lstStyle/>
+          <a:p>
+            <a:pPr marL="0" marR="0" lvl="0" indent="0" algn="l" defTabSz="914400" rtl="0" eaLnBrk="1" fontAlgn="auto" latinLnBrk="0" hangingPunct="1">
+              <a:lnSpc>
+                <a:spcPct val="100000"/>
+              </a:lnSpc>
+              <a:spcBef>
+                <a:spcPts val="0"/>
+              </a:spcBef>
+              <a:spcAft>
+                <a:spcPts val="0"/>
+              </a:spcAft>
+              <a:buClrTx/>
+              <a:buSzTx/>
+              <a:buFontTx/>
+              <a:buNone/>
+              <a:tabLst/>
+              <a:defRPr/>
+            </a:pPr>
+            <a:r>
+              <a:rPr kumimoji="0" lang="de-DE" sz="1800" b="0" i="0" u="none" strike="noStrike" kern="1200" cap="none" spc="0" normalizeH="0" baseline="0" noProof="0" dirty="0">
+                <a:ln>
+                  <a:noFill/>
+                </a:ln>
+                <a:solidFill>
+                  <a:prstClr val="black"/>
+                </a:solidFill>
+                <a:effectLst/>
+                <a:uLnTx/>
+                <a:uFillTx/>
+                <a:latin typeface="Calibri" panose="020F0502020204030204"/>
+                <a:ea typeface="+mn-ea"/>
+                <a:cs typeface="+mn-cs"/>
+              </a:rPr>
+              <a:t>Ca. </a:t>
+            </a:r>
+            <a:r>
+              <a:rPr lang="de-DE" dirty="0">
+                <a:solidFill>
+                  <a:prstClr val="black"/>
+                </a:solidFill>
+                <a:latin typeface="Calibri" panose="020F0502020204030204"/>
+              </a:rPr>
+              <a:t>26.7</a:t>
+            </a:r>
+            <a:r>
+              <a:rPr kumimoji="0" lang="de-DE" sz="1800" b="0" i="0" u="none" strike="noStrike" kern="1200" cap="none" spc="0" normalizeH="0" baseline="0" noProof="0" dirty="0">
+                <a:ln>
+                  <a:noFill/>
+                </a:ln>
+                <a:solidFill>
+                  <a:prstClr val="black"/>
+                </a:solidFill>
+                <a:effectLst/>
+                <a:uLnTx/>
+                <a:uFillTx/>
+                <a:latin typeface="Calibri" panose="020F0502020204030204"/>
+                <a:ea typeface="+mn-ea"/>
+                <a:cs typeface="+mn-cs"/>
+              </a:rPr>
+              <a:t> mm</a:t>
+            </a:r>
+          </a:p>
+        </p:txBody>
+      </p:sp>
+      <p:sp>
+        <p:nvSpPr>
+          <p:cNvPr id="70" name="Textfeld 25">
+            <a:extLst>
+              <a:ext uri="{FF2B5EF4-FFF2-40B4-BE49-F238E27FC236}">
+                <a16:creationId xmlns:a16="http://schemas.microsoft.com/office/drawing/2014/main" id="{14A01BA8-C0D7-DF0D-EA9F-BB5637C84581}"/>
+              </a:ext>
+            </a:extLst>
+          </p:cNvPr>
+          <p:cNvSpPr txBox="1"/>
+          <p:nvPr/>
+        </p:nvSpPr>
+        <p:spPr>
+          <a:xfrm>
+            <a:off x="5024149" y="2046060"/>
+            <a:ext cx="1367278" cy="369332"/>
+          </a:xfrm>
+          <a:prstGeom prst="rect">
+            <a:avLst/>
+          </a:prstGeom>
+          <a:noFill/>
+        </p:spPr>
+        <p:txBody>
+          <a:bodyPr wrap="square" rtlCol="0">
+            <a:spAutoFit/>
+          </a:bodyPr>
+          <a:lstStyle/>
+          <a:p>
+            <a:pPr marL="0" marR="0" lvl="0" indent="0" algn="l" defTabSz="914400" rtl="0" eaLnBrk="1" fontAlgn="auto" latinLnBrk="0" hangingPunct="1">
+              <a:lnSpc>
+                <a:spcPct val="100000"/>
+              </a:lnSpc>
+              <a:spcBef>
+                <a:spcPts val="0"/>
+              </a:spcBef>
+              <a:spcAft>
+                <a:spcPts val="0"/>
+              </a:spcAft>
+              <a:buClrTx/>
+              <a:buSzTx/>
+              <a:buFontTx/>
+              <a:buNone/>
+              <a:tabLst/>
+              <a:defRPr/>
+            </a:pPr>
+            <a:r>
+              <a:rPr kumimoji="0" lang="de-DE" sz="1800" b="0" i="0" u="none" strike="noStrike" kern="1200" cap="none" spc="0" normalizeH="0" baseline="0" noProof="0" dirty="0">
+                <a:ln>
+                  <a:noFill/>
+                </a:ln>
+                <a:solidFill>
+                  <a:prstClr val="black"/>
+                </a:solidFill>
+                <a:effectLst/>
+                <a:uLnTx/>
+                <a:uFillTx/>
+                <a:latin typeface="Calibri" panose="020F0502020204030204"/>
+                <a:ea typeface="+mn-ea"/>
+                <a:cs typeface="+mn-cs"/>
+              </a:rPr>
+              <a:t>Ca. 3.3 mm</a:t>
+            </a:r>
+          </a:p>
+        </p:txBody>
+      </p:sp>
+      <p:sp>
+        <p:nvSpPr>
+          <p:cNvPr id="71" name="Textfeld 25">
+            <a:extLst>
+              <a:ext uri="{FF2B5EF4-FFF2-40B4-BE49-F238E27FC236}">
+                <a16:creationId xmlns:a16="http://schemas.microsoft.com/office/drawing/2014/main" id="{71633B82-979D-9563-54DB-8B521AD7C5E1}"/>
+              </a:ext>
+            </a:extLst>
+          </p:cNvPr>
+          <p:cNvSpPr txBox="1"/>
+          <p:nvPr/>
+        </p:nvSpPr>
+        <p:spPr>
+          <a:xfrm rot="16200000">
+            <a:off x="3969534" y="1721352"/>
+            <a:ext cx="1367278" cy="369332"/>
+          </a:xfrm>
+          <a:prstGeom prst="rect">
+            <a:avLst/>
+          </a:prstGeom>
+          <a:noFill/>
+        </p:spPr>
+        <p:txBody>
+          <a:bodyPr wrap="square" rtlCol="0">
+            <a:spAutoFit/>
+          </a:bodyPr>
+          <a:lstStyle/>
+          <a:p>
+            <a:pPr marL="0" marR="0" lvl="0" indent="0" algn="l" defTabSz="914400" rtl="0" eaLnBrk="1" fontAlgn="auto" latinLnBrk="0" hangingPunct="1">
+              <a:lnSpc>
+                <a:spcPct val="100000"/>
+              </a:lnSpc>
+              <a:spcBef>
+                <a:spcPts val="0"/>
+              </a:spcBef>
+              <a:spcAft>
+                <a:spcPts val="0"/>
+              </a:spcAft>
+              <a:buClrTx/>
+              <a:buSzTx/>
+              <a:buFontTx/>
+              <a:buNone/>
+              <a:tabLst/>
+              <a:defRPr/>
+            </a:pPr>
+            <a:r>
+              <a:rPr kumimoji="0" lang="de-DE" sz="1800" b="0" i="0" u="none" strike="noStrike" kern="1200" cap="none" spc="0" normalizeH="0" baseline="0" noProof="0" dirty="0">
+                <a:ln>
+                  <a:noFill/>
+                </a:ln>
+                <a:solidFill>
+                  <a:prstClr val="black"/>
+                </a:solidFill>
+                <a:effectLst/>
+                <a:uLnTx/>
+                <a:uFillTx/>
+                <a:latin typeface="Calibri" panose="020F0502020204030204"/>
+                <a:ea typeface="+mn-ea"/>
+                <a:cs typeface="+mn-cs"/>
+              </a:rPr>
+              <a:t>Ca. </a:t>
+            </a:r>
+            <a:r>
+              <a:rPr lang="de-DE" dirty="0">
+                <a:solidFill>
+                  <a:prstClr val="black"/>
+                </a:solidFill>
+                <a:latin typeface="Calibri" panose="020F0502020204030204"/>
+              </a:rPr>
+              <a:t>14.5</a:t>
+            </a:r>
+            <a:r>
+              <a:rPr kumimoji="0" lang="de-DE" sz="1800" b="0" i="0" u="none" strike="noStrike" kern="1200" cap="none" spc="0" normalizeH="0" baseline="0" noProof="0" dirty="0">
+                <a:ln>
+                  <a:noFill/>
+                </a:ln>
+                <a:solidFill>
+                  <a:prstClr val="black"/>
+                </a:solidFill>
+                <a:effectLst/>
+                <a:uLnTx/>
+                <a:uFillTx/>
+                <a:latin typeface="Calibri" panose="020F0502020204030204"/>
+                <a:ea typeface="+mn-ea"/>
+                <a:cs typeface="+mn-cs"/>
+              </a:rPr>
+              <a:t> mm</a:t>
+            </a:r>
+          </a:p>
+        </p:txBody>
+      </p:sp>
+      <p:sp>
+        <p:nvSpPr>
+          <p:cNvPr id="72" name="Textfeld 25">
+            <a:extLst>
+              <a:ext uri="{FF2B5EF4-FFF2-40B4-BE49-F238E27FC236}">
+                <a16:creationId xmlns:a16="http://schemas.microsoft.com/office/drawing/2014/main" id="{1847DD11-D27C-6734-769D-C70493D80873}"/>
+              </a:ext>
+            </a:extLst>
+          </p:cNvPr>
+          <p:cNvSpPr txBox="1"/>
+          <p:nvPr/>
+        </p:nvSpPr>
+        <p:spPr>
+          <a:xfrm>
+            <a:off x="5146393" y="4092852"/>
+            <a:ext cx="1367278" cy="369332"/>
+          </a:xfrm>
+          <a:prstGeom prst="rect">
+            <a:avLst/>
+          </a:prstGeom>
+          <a:noFill/>
+        </p:spPr>
+        <p:txBody>
+          <a:bodyPr wrap="square" rtlCol="0">
+            <a:spAutoFit/>
+          </a:bodyPr>
+          <a:lstStyle/>
+          <a:p>
+            <a:pPr marL="0" marR="0" lvl="0" indent="0" algn="l" defTabSz="914400" rtl="0" eaLnBrk="1" fontAlgn="auto" latinLnBrk="0" hangingPunct="1">
+              <a:lnSpc>
+                <a:spcPct val="100000"/>
+              </a:lnSpc>
+              <a:spcBef>
+                <a:spcPts val="0"/>
+              </a:spcBef>
+              <a:spcAft>
+                <a:spcPts val="0"/>
+              </a:spcAft>
+              <a:buClrTx/>
+              <a:buSzTx/>
+              <a:buFontTx/>
+              <a:buNone/>
+              <a:tabLst/>
+              <a:defRPr/>
+            </a:pPr>
+            <a:r>
+              <a:rPr kumimoji="0" lang="de-DE" sz="1800" b="0" i="0" u="none" strike="noStrike" kern="1200" cap="none" spc="0" normalizeH="0" baseline="0" noProof="0" dirty="0">
+                <a:ln>
+                  <a:noFill/>
+                </a:ln>
+                <a:solidFill>
+                  <a:prstClr val="black"/>
+                </a:solidFill>
+                <a:effectLst/>
+                <a:uLnTx/>
+                <a:uFillTx/>
+                <a:latin typeface="Calibri" panose="020F0502020204030204"/>
+                <a:ea typeface="+mn-ea"/>
+                <a:cs typeface="+mn-cs"/>
+              </a:rPr>
+              <a:t>Ca. </a:t>
+            </a:r>
+            <a:r>
+              <a:rPr lang="de-DE" dirty="0">
+                <a:solidFill>
+                  <a:prstClr val="black"/>
+                </a:solidFill>
+                <a:latin typeface="Calibri" panose="020F0502020204030204"/>
+              </a:rPr>
+              <a:t>31.3</a:t>
+            </a:r>
+            <a:r>
+              <a:rPr kumimoji="0" lang="de-DE" sz="1800" b="0" i="0" u="none" strike="noStrike" kern="1200" cap="none" spc="0" normalizeH="0" baseline="0" noProof="0" dirty="0">
+                <a:ln>
+                  <a:noFill/>
+                </a:ln>
+                <a:solidFill>
+                  <a:prstClr val="black"/>
+                </a:solidFill>
+                <a:effectLst/>
+                <a:uLnTx/>
+                <a:uFillTx/>
+                <a:latin typeface="Calibri" panose="020F0502020204030204"/>
+                <a:ea typeface="+mn-ea"/>
+                <a:cs typeface="+mn-cs"/>
+              </a:rPr>
+              <a:t> mm</a:t>
+            </a:r>
+          </a:p>
+        </p:txBody>
+      </p:sp>
+      <p:sp>
+        <p:nvSpPr>
+          <p:cNvPr id="73" name="Oval 72">
+            <a:extLst>
+              <a:ext uri="{FF2B5EF4-FFF2-40B4-BE49-F238E27FC236}">
+                <a16:creationId xmlns:a16="http://schemas.microsoft.com/office/drawing/2014/main" id="{33970B35-BF73-A093-E30D-B61BAFDC5A62}"/>
+              </a:ext>
+            </a:extLst>
+          </p:cNvPr>
+          <p:cNvSpPr/>
+          <p:nvPr/>
+        </p:nvSpPr>
+        <p:spPr>
+          <a:xfrm>
+            <a:off x="4757941" y="2556656"/>
+            <a:ext cx="388452" cy="369330"/>
+          </a:xfrm>
+          <a:prstGeom prst="ellipse">
+            <a:avLst/>
+          </a:prstGeom>
+          <a:noFill/>
+          <a:ln>
+            <a:solidFill>
+              <a:schemeClr val="tx1"/>
+            </a:solidFill>
+          </a:ln>
+        </p:spPr>
+        <p:style>
+          <a:lnRef idx="2">
+            <a:schemeClr val="accent1">
+              <a:shade val="50000"/>
+            </a:schemeClr>
+          </a:lnRef>
+          <a:fillRef idx="1">
+            <a:schemeClr val="accent1"/>
+          </a:fillRef>
+          <a:effectRef idx="0">
+            <a:schemeClr val="accent1"/>
+          </a:effectRef>
+          <a:fontRef idx="minor">
+            <a:schemeClr val="lt1"/>
+          </a:fontRef>
+        </p:style>
+        <p:txBody>
+          <a:bodyPr rtlCol="0" anchor="ctr"/>
+          <a:lstStyle/>
+          <a:p>
+            <a:pPr algn="ctr"/>
+            <a:endParaRPr lang="en-GB" dirty="0"/>
+          </a:p>
+        </p:txBody>
+      </p:sp>
+      <p:cxnSp>
+        <p:nvCxnSpPr>
+          <p:cNvPr id="74" name="Straight Connector 73">
+            <a:extLst>
+              <a:ext uri="{FF2B5EF4-FFF2-40B4-BE49-F238E27FC236}">
+                <a16:creationId xmlns:a16="http://schemas.microsoft.com/office/drawing/2014/main" id="{E595AB2C-EF68-4851-0471-72F5DD48654D}"/>
+              </a:ext>
+            </a:extLst>
+          </p:cNvPr>
+          <p:cNvCxnSpPr>
+            <a:stCxn id="73" idx="1"/>
+            <a:endCxn id="73" idx="5"/>
+          </p:cNvCxnSpPr>
+          <p:nvPr/>
+        </p:nvCxnSpPr>
+        <p:spPr>
+          <a:xfrm>
+            <a:off x="4814828" y="2610743"/>
+            <a:ext cx="274678" cy="261156"/>
+          </a:xfrm>
+          <a:prstGeom prst="line">
+            <a:avLst/>
+          </a:prstGeom>
+          <a:ln>
+            <a:solidFill>
+              <a:schemeClr val="tx1"/>
+            </a:solidFill>
+          </a:ln>
+        </p:spPr>
+        <p:style>
+          <a:lnRef idx="1">
+            <a:schemeClr val="accent1"/>
+          </a:lnRef>
+          <a:fillRef idx="0">
+            <a:schemeClr val="accent1"/>
+          </a:fillRef>
+          <a:effectRef idx="0">
+            <a:schemeClr val="accent1"/>
+          </a:effectRef>
+          <a:fontRef idx="minor">
+            <a:schemeClr val="tx1"/>
+          </a:fontRef>
+        </p:style>
+      </p:cxnSp>
+      <p:cxnSp>
+        <p:nvCxnSpPr>
+          <p:cNvPr id="75" name="Straight Connector 74">
+            <a:extLst>
+              <a:ext uri="{FF2B5EF4-FFF2-40B4-BE49-F238E27FC236}">
+                <a16:creationId xmlns:a16="http://schemas.microsoft.com/office/drawing/2014/main" id="{C78B94A1-B877-EDA1-FAB2-905F888D0391}"/>
+              </a:ext>
+            </a:extLst>
+          </p:cNvPr>
+          <p:cNvCxnSpPr>
+            <a:stCxn id="73" idx="3"/>
+            <a:endCxn id="73" idx="7"/>
+          </p:cNvCxnSpPr>
+          <p:nvPr/>
+        </p:nvCxnSpPr>
+        <p:spPr>
+          <a:xfrm flipV="1">
+            <a:off x="4814828" y="2610743"/>
+            <a:ext cx="274678" cy="261156"/>
+          </a:xfrm>
+          <a:prstGeom prst="line">
+            <a:avLst/>
+          </a:prstGeom>
+          <a:ln>
+            <a:solidFill>
+              <a:schemeClr val="tx1"/>
+            </a:solidFill>
+          </a:ln>
+        </p:spPr>
+        <p:style>
+          <a:lnRef idx="1">
+            <a:schemeClr val="accent1"/>
+          </a:lnRef>
+          <a:fillRef idx="0">
+            <a:schemeClr val="accent1"/>
+          </a:fillRef>
+          <a:effectRef idx="0">
+            <a:schemeClr val="accent1"/>
+          </a:effectRef>
+          <a:fontRef idx="minor">
+            <a:schemeClr val="tx1"/>
+          </a:fontRef>
+        </p:style>
+      </p:cxnSp>
+      <p:sp>
+        <p:nvSpPr>
+          <p:cNvPr id="76" name="Oval 75">
+            <a:extLst>
+              <a:ext uri="{FF2B5EF4-FFF2-40B4-BE49-F238E27FC236}">
+                <a16:creationId xmlns:a16="http://schemas.microsoft.com/office/drawing/2014/main" id="{AD9B8ACE-4E6B-8F6F-45A3-2816550B8966}"/>
+              </a:ext>
+            </a:extLst>
+          </p:cNvPr>
+          <p:cNvSpPr/>
+          <p:nvPr/>
+        </p:nvSpPr>
+        <p:spPr>
+          <a:xfrm>
+            <a:off x="4780952" y="3797639"/>
+            <a:ext cx="388452" cy="369330"/>
+          </a:xfrm>
+          <a:prstGeom prst="ellipse">
+            <a:avLst/>
+          </a:prstGeom>
+          <a:noFill/>
+          <a:ln>
+            <a:solidFill>
+              <a:schemeClr val="tx1"/>
+            </a:solidFill>
+          </a:ln>
+        </p:spPr>
+        <p:style>
+          <a:lnRef idx="2">
+            <a:schemeClr val="accent1">
+              <a:shade val="50000"/>
+            </a:schemeClr>
+          </a:lnRef>
+          <a:fillRef idx="1">
+            <a:schemeClr val="accent1"/>
+          </a:fillRef>
+          <a:effectRef idx="0">
+            <a:schemeClr val="accent1"/>
+          </a:effectRef>
+          <a:fontRef idx="minor">
+            <a:schemeClr val="lt1"/>
+          </a:fontRef>
+        </p:style>
+        <p:txBody>
+          <a:bodyPr rtlCol="0" anchor="ctr"/>
+          <a:lstStyle/>
+          <a:p>
+            <a:pPr algn="ctr"/>
+            <a:endParaRPr lang="en-GB" dirty="0"/>
+          </a:p>
+        </p:txBody>
+      </p:sp>
+      <p:cxnSp>
+        <p:nvCxnSpPr>
+          <p:cNvPr id="77" name="Straight Connector 76">
+            <a:extLst>
+              <a:ext uri="{FF2B5EF4-FFF2-40B4-BE49-F238E27FC236}">
+                <a16:creationId xmlns:a16="http://schemas.microsoft.com/office/drawing/2014/main" id="{C143756B-29C3-4957-44B1-D90E58C1674E}"/>
+              </a:ext>
+            </a:extLst>
+          </p:cNvPr>
+          <p:cNvCxnSpPr>
+            <a:stCxn id="76" idx="1"/>
+            <a:endCxn id="76" idx="5"/>
+          </p:cNvCxnSpPr>
+          <p:nvPr/>
+        </p:nvCxnSpPr>
+        <p:spPr>
+          <a:xfrm>
+            <a:off x="4837839" y="3851726"/>
+            <a:ext cx="274678" cy="261156"/>
+          </a:xfrm>
+          <a:prstGeom prst="line">
+            <a:avLst/>
+          </a:prstGeom>
+          <a:ln>
+            <a:solidFill>
+              <a:schemeClr val="tx1"/>
+            </a:solidFill>
+          </a:ln>
+        </p:spPr>
+        <p:style>
+          <a:lnRef idx="1">
+            <a:schemeClr val="accent1"/>
+          </a:lnRef>
+          <a:fillRef idx="0">
+            <a:schemeClr val="accent1"/>
+          </a:fillRef>
+          <a:effectRef idx="0">
+            <a:schemeClr val="accent1"/>
+          </a:effectRef>
+          <a:fontRef idx="minor">
+            <a:schemeClr val="tx1"/>
+          </a:fontRef>
+        </p:style>
+      </p:cxnSp>
+      <p:cxnSp>
+        <p:nvCxnSpPr>
+          <p:cNvPr id="78" name="Straight Connector 77">
+            <a:extLst>
+              <a:ext uri="{FF2B5EF4-FFF2-40B4-BE49-F238E27FC236}">
+                <a16:creationId xmlns:a16="http://schemas.microsoft.com/office/drawing/2014/main" id="{D4DB9B87-9ED0-2673-679B-7F56385667B2}"/>
+              </a:ext>
+            </a:extLst>
+          </p:cNvPr>
+          <p:cNvCxnSpPr>
+            <a:stCxn id="76" idx="3"/>
+            <a:endCxn id="76" idx="7"/>
+          </p:cNvCxnSpPr>
+          <p:nvPr/>
+        </p:nvCxnSpPr>
+        <p:spPr>
+          <a:xfrm flipV="1">
+            <a:off x="4837839" y="3851726"/>
+            <a:ext cx="274678" cy="261156"/>
+          </a:xfrm>
+          <a:prstGeom prst="line">
+            <a:avLst/>
+          </a:prstGeom>
+          <a:ln>
+            <a:solidFill>
+              <a:schemeClr val="tx1"/>
+            </a:solidFill>
+          </a:ln>
+        </p:spPr>
+        <p:style>
+          <a:lnRef idx="1">
+            <a:schemeClr val="accent1"/>
+          </a:lnRef>
+          <a:fillRef idx="0">
+            <a:schemeClr val="accent1"/>
+          </a:fillRef>
+          <a:effectRef idx="0">
+            <a:schemeClr val="accent1"/>
+          </a:effectRef>
+          <a:fontRef idx="minor">
+            <a:schemeClr val="tx1"/>
+          </a:fontRef>
+        </p:style>
+      </p:cxnSp>
+      <p:cxnSp>
+        <p:nvCxnSpPr>
+          <p:cNvPr id="79" name="Gerade Verbindung mit Pfeil 1">
+            <a:extLst>
+              <a:ext uri="{FF2B5EF4-FFF2-40B4-BE49-F238E27FC236}">
+                <a16:creationId xmlns:a16="http://schemas.microsoft.com/office/drawing/2014/main" id="{C38B4B24-2416-42F0-B8C4-6EACDE4D9DF8}"/>
+              </a:ext>
+            </a:extLst>
+          </p:cNvPr>
+          <p:cNvCxnSpPr>
+            <a:cxnSpLocks/>
+          </p:cNvCxnSpPr>
+          <p:nvPr/>
+        </p:nvCxnSpPr>
+        <p:spPr>
+          <a:xfrm>
+            <a:off x="2374571" y="3978584"/>
+            <a:ext cx="2577596" cy="5063"/>
+          </a:xfrm>
+          <a:prstGeom prst="straightConnector1">
+            <a:avLst/>
+          </a:prstGeom>
+          <a:ln>
+            <a:solidFill>
+              <a:schemeClr val="tx1"/>
+            </a:solidFill>
+            <a:headEnd type="triangle"/>
+            <a:tailEnd type="triangle"/>
+          </a:ln>
+        </p:spPr>
+        <p:style>
+          <a:lnRef idx="1">
+            <a:schemeClr val="accent1"/>
+          </a:lnRef>
+          <a:fillRef idx="0">
+            <a:schemeClr val="accent1"/>
+          </a:fillRef>
+          <a:effectRef idx="0">
+            <a:schemeClr val="accent1"/>
+          </a:effectRef>
+          <a:fontRef idx="minor">
+            <a:schemeClr val="tx1"/>
+          </a:fontRef>
+        </p:style>
+      </p:cxnSp>
+      <p:sp>
+        <p:nvSpPr>
+          <p:cNvPr id="83" name="Textfeld 25">
+            <a:extLst>
+              <a:ext uri="{FF2B5EF4-FFF2-40B4-BE49-F238E27FC236}">
+                <a16:creationId xmlns:a16="http://schemas.microsoft.com/office/drawing/2014/main" id="{0A625F1F-569F-6347-6745-47AE2B9DEF10}"/>
+              </a:ext>
+            </a:extLst>
+          </p:cNvPr>
+          <p:cNvSpPr txBox="1"/>
+          <p:nvPr/>
+        </p:nvSpPr>
+        <p:spPr>
+          <a:xfrm>
+            <a:off x="3179701" y="4024914"/>
+            <a:ext cx="1367278" cy="369332"/>
+          </a:xfrm>
+          <a:prstGeom prst="rect">
+            <a:avLst/>
+          </a:prstGeom>
+          <a:noFill/>
+        </p:spPr>
+        <p:txBody>
+          <a:bodyPr wrap="square" rtlCol="0">
+            <a:spAutoFit/>
+          </a:bodyPr>
+          <a:lstStyle/>
+          <a:p>
+            <a:pPr marL="0" marR="0" lvl="0" indent="0" algn="l" defTabSz="914400" rtl="0" eaLnBrk="1" fontAlgn="auto" latinLnBrk="0" hangingPunct="1">
+              <a:lnSpc>
+                <a:spcPct val="100000"/>
+              </a:lnSpc>
+              <a:spcBef>
+                <a:spcPts val="0"/>
+              </a:spcBef>
+              <a:spcAft>
+                <a:spcPts val="0"/>
+              </a:spcAft>
+              <a:buClrTx/>
+              <a:buSzTx/>
+              <a:buFontTx/>
+              <a:buNone/>
+              <a:tabLst/>
+              <a:defRPr/>
+            </a:pPr>
+            <a:r>
+              <a:rPr kumimoji="0" lang="de-DE" sz="1800" b="0" i="0" u="none" strike="noStrike" kern="1200" cap="none" spc="0" normalizeH="0" baseline="0" noProof="0" dirty="0">
+                <a:ln>
+                  <a:noFill/>
+                </a:ln>
+                <a:solidFill>
+                  <a:prstClr val="black"/>
+                </a:solidFill>
+                <a:effectLst/>
+                <a:uLnTx/>
+                <a:uFillTx/>
+                <a:latin typeface="Calibri" panose="020F0502020204030204"/>
+                <a:ea typeface="+mn-ea"/>
+                <a:cs typeface="+mn-cs"/>
+              </a:rPr>
+              <a:t>Ca. </a:t>
+            </a:r>
+            <a:r>
+              <a:rPr lang="de-DE" dirty="0">
+                <a:solidFill>
+                  <a:prstClr val="black"/>
+                </a:solidFill>
+                <a:latin typeface="Calibri" panose="020F0502020204030204"/>
+              </a:rPr>
+              <a:t>38.7</a:t>
+            </a:r>
+            <a:r>
+              <a:rPr kumimoji="0" lang="de-DE" sz="1800" b="0" i="0" u="none" strike="noStrike" kern="1200" cap="none" spc="0" normalizeH="0" baseline="0" noProof="0" dirty="0">
+                <a:ln>
+                  <a:noFill/>
+                </a:ln>
+                <a:solidFill>
+                  <a:prstClr val="black"/>
+                </a:solidFill>
+                <a:effectLst/>
+                <a:uLnTx/>
+                <a:uFillTx/>
+                <a:latin typeface="Calibri" panose="020F0502020204030204"/>
+                <a:ea typeface="+mn-ea"/>
+                <a:cs typeface="+mn-cs"/>
+              </a:rPr>
+              <a:t> mm</a:t>
+            </a:r>
+          </a:p>
+        </p:txBody>
+      </p:sp>
+      <p:cxnSp>
+        <p:nvCxnSpPr>
+          <p:cNvPr id="84" name="Gerade Verbindung mit Pfeil 7">
+            <a:extLst>
+              <a:ext uri="{FF2B5EF4-FFF2-40B4-BE49-F238E27FC236}">
+                <a16:creationId xmlns:a16="http://schemas.microsoft.com/office/drawing/2014/main" id="{6779554B-F03F-6430-B4A4-AE19C4CB3D59}"/>
+              </a:ext>
+            </a:extLst>
+          </p:cNvPr>
+          <p:cNvCxnSpPr>
+            <a:cxnSpLocks/>
+          </p:cNvCxnSpPr>
+          <p:nvPr/>
+        </p:nvCxnSpPr>
+        <p:spPr>
+          <a:xfrm flipV="1">
+            <a:off x="5318449" y="2770286"/>
+            <a:ext cx="0" cy="1178949"/>
+          </a:xfrm>
+          <a:prstGeom prst="straightConnector1">
+            <a:avLst/>
+          </a:prstGeom>
+          <a:ln>
+            <a:solidFill>
+              <a:schemeClr val="tx1"/>
+            </a:solidFill>
+            <a:headEnd type="triangle"/>
+            <a:tailEnd type="triangle"/>
+          </a:ln>
+        </p:spPr>
+        <p:style>
+          <a:lnRef idx="1">
+            <a:schemeClr val="accent1"/>
+          </a:lnRef>
+          <a:fillRef idx="0">
+            <a:schemeClr val="accent1"/>
+          </a:fillRef>
+          <a:effectRef idx="0">
+            <a:schemeClr val="accent1"/>
+          </a:effectRef>
+          <a:fontRef idx="minor">
+            <a:schemeClr val="tx1"/>
+          </a:fontRef>
+        </p:style>
+      </p:cxnSp>
+      <p:sp>
+        <p:nvSpPr>
+          <p:cNvPr id="85" name="Textfeld 25">
+            <a:extLst>
+              <a:ext uri="{FF2B5EF4-FFF2-40B4-BE49-F238E27FC236}">
+                <a16:creationId xmlns:a16="http://schemas.microsoft.com/office/drawing/2014/main" id="{76BE0EAB-65F7-C720-DF48-9A726E02041F}"/>
+              </a:ext>
+            </a:extLst>
+          </p:cNvPr>
+          <p:cNvSpPr txBox="1"/>
+          <p:nvPr/>
+        </p:nvSpPr>
+        <p:spPr>
+          <a:xfrm rot="16200000">
+            <a:off x="4899740" y="3110279"/>
+            <a:ext cx="1367278" cy="369332"/>
+          </a:xfrm>
+          <a:prstGeom prst="rect">
+            <a:avLst/>
+          </a:prstGeom>
+          <a:noFill/>
+        </p:spPr>
+        <p:txBody>
+          <a:bodyPr wrap="square" rtlCol="0">
+            <a:spAutoFit/>
+          </a:bodyPr>
+          <a:lstStyle/>
+          <a:p>
+            <a:pPr marL="0" marR="0" lvl="0" indent="0" algn="l" defTabSz="914400" rtl="0" eaLnBrk="1" fontAlgn="auto" latinLnBrk="0" hangingPunct="1">
+              <a:lnSpc>
+                <a:spcPct val="100000"/>
+              </a:lnSpc>
+              <a:spcBef>
+                <a:spcPts val="0"/>
+              </a:spcBef>
+              <a:spcAft>
+                <a:spcPts val="0"/>
+              </a:spcAft>
+              <a:buClrTx/>
+              <a:buSzTx/>
+              <a:buFontTx/>
+              <a:buNone/>
+              <a:tabLst/>
+              <a:defRPr/>
+            </a:pPr>
+            <a:r>
+              <a:rPr kumimoji="0" lang="de-DE" sz="1800" b="0" i="0" u="none" strike="noStrike" kern="1200" cap="none" spc="0" normalizeH="0" baseline="0" noProof="0" dirty="0">
+                <a:ln>
+                  <a:noFill/>
+                </a:ln>
+                <a:solidFill>
+                  <a:prstClr val="black"/>
+                </a:solidFill>
+                <a:effectLst/>
+                <a:uLnTx/>
+                <a:uFillTx/>
+                <a:latin typeface="Calibri" panose="020F0502020204030204"/>
+                <a:ea typeface="+mn-ea"/>
+                <a:cs typeface="+mn-cs"/>
+              </a:rPr>
+              <a:t>Ca. 33.5 mm</a:t>
+            </a:r>
+          </a:p>
+        </p:txBody>
+      </p:sp>
+      <p:sp>
+        <p:nvSpPr>
+          <p:cNvPr id="3" name="TextBox 2">
+            <a:extLst>
+              <a:ext uri="{FF2B5EF4-FFF2-40B4-BE49-F238E27FC236}">
+                <a16:creationId xmlns:a16="http://schemas.microsoft.com/office/drawing/2014/main" id="{954C7D5E-2207-47CF-B55D-A56E1F5C694E}"/>
+              </a:ext>
+            </a:extLst>
+          </p:cNvPr>
+          <p:cNvSpPr txBox="1"/>
+          <p:nvPr/>
+        </p:nvSpPr>
+        <p:spPr>
+          <a:xfrm>
+            <a:off x="684848" y="367282"/>
+            <a:ext cx="3072316" cy="461665"/>
+          </a:xfrm>
+          <a:prstGeom prst="rect">
+            <a:avLst/>
+          </a:prstGeom>
+          <a:noFill/>
+        </p:spPr>
+        <p:txBody>
+          <a:bodyPr wrap="none" rtlCol="0">
+            <a:spAutoFit/>
+          </a:bodyPr>
+          <a:lstStyle/>
+          <a:p>
+            <a:r>
+              <a:rPr lang="de-DE" sz="2400" b="1" dirty="0"/>
+              <a:t>Kühlkörper Bohrungen</a:t>
+            </a:r>
+            <a:endParaRPr lang="en-GB" sz="2400" b="1" dirty="0"/>
+          </a:p>
+        </p:txBody>
+      </p:sp>
+    </p:spTree>
+    <p:extLst>
+      <p:ext uri="{BB962C8B-B14F-4D97-AF65-F5344CB8AC3E}">
+        <p14:creationId xmlns:p14="http://schemas.microsoft.com/office/powerpoint/2010/main" val="589981970"/>
+      </p:ext>
+    </p:extLst>
+  </p:cSld>
+  <p:clrMapOvr>
+    <a:masterClrMapping/>
+  </p:clrMapOvr>
+</p:sld>
+</file>
+
 <file path=ppt/theme/theme1.xml><?xml version="1.0" encoding="utf-8"?>
 <a:theme xmlns:a="http://schemas.openxmlformats.org/drawingml/2006/main" name="Office">
   <a:themeElements>

</xml_diff>

<commit_message>
added OC function over ITRIP pin and solved issue1
</commit_message>
<xml_diff>
--- a/docs/PCB_interfaces.pptx
+++ b/docs/PCB_interfaces.pptx
@@ -260,7 +260,7 @@
           <a:p>
             <a:fld id="{5C26CB86-9D02-4EAF-92D6-993F0AA89364}" type="datetimeFigureOut">
               <a:rPr lang="de-DE" smtClean="0"/>
-              <a:t>09.01.2023</a:t>
+              <a:t>24.01.2023</a:t>
             </a:fld>
             <a:endParaRPr lang="de-DE"/>
           </a:p>
@@ -314,7 +314,7 @@
           <a:p>
             <a:fld id="{95176C13-B2CD-406A-8CCB-6356FE93C9A4}" type="slidenum">
               <a:rPr lang="de-DE" smtClean="0"/>
-              <a:t>‹#›</a:t>
+              <a:t>‹Nr.›</a:t>
             </a:fld>
             <a:endParaRPr lang="de-DE"/>
           </a:p>
@@ -458,7 +458,7 @@
           <a:p>
             <a:fld id="{5C26CB86-9D02-4EAF-92D6-993F0AA89364}" type="datetimeFigureOut">
               <a:rPr lang="de-DE" smtClean="0"/>
-              <a:t>09.01.2023</a:t>
+              <a:t>24.01.2023</a:t>
             </a:fld>
             <a:endParaRPr lang="de-DE"/>
           </a:p>
@@ -512,7 +512,7 @@
           <a:p>
             <a:fld id="{95176C13-B2CD-406A-8CCB-6356FE93C9A4}" type="slidenum">
               <a:rPr lang="de-DE" smtClean="0"/>
-              <a:t>‹#›</a:t>
+              <a:t>‹Nr.›</a:t>
             </a:fld>
             <a:endParaRPr lang="de-DE"/>
           </a:p>
@@ -666,7 +666,7 @@
           <a:p>
             <a:fld id="{5C26CB86-9D02-4EAF-92D6-993F0AA89364}" type="datetimeFigureOut">
               <a:rPr lang="de-DE" smtClean="0"/>
-              <a:t>09.01.2023</a:t>
+              <a:t>24.01.2023</a:t>
             </a:fld>
             <a:endParaRPr lang="de-DE"/>
           </a:p>
@@ -720,7 +720,7 @@
           <a:p>
             <a:fld id="{95176C13-B2CD-406A-8CCB-6356FE93C9A4}" type="slidenum">
               <a:rPr lang="de-DE" smtClean="0"/>
-              <a:t>‹#›</a:t>
+              <a:t>‹Nr.›</a:t>
             </a:fld>
             <a:endParaRPr lang="de-DE"/>
           </a:p>
@@ -864,7 +864,7 @@
           <a:p>
             <a:fld id="{5C26CB86-9D02-4EAF-92D6-993F0AA89364}" type="datetimeFigureOut">
               <a:rPr lang="de-DE" smtClean="0"/>
-              <a:t>09.01.2023</a:t>
+              <a:t>24.01.2023</a:t>
             </a:fld>
             <a:endParaRPr lang="de-DE"/>
           </a:p>
@@ -918,7 +918,7 @@
           <a:p>
             <a:fld id="{95176C13-B2CD-406A-8CCB-6356FE93C9A4}" type="slidenum">
               <a:rPr lang="de-DE" smtClean="0"/>
-              <a:t>‹#›</a:t>
+              <a:t>‹Nr.›</a:t>
             </a:fld>
             <a:endParaRPr lang="de-DE"/>
           </a:p>
@@ -1139,7 +1139,7 @@
           <a:p>
             <a:fld id="{5C26CB86-9D02-4EAF-92D6-993F0AA89364}" type="datetimeFigureOut">
               <a:rPr lang="de-DE" smtClean="0"/>
-              <a:t>09.01.2023</a:t>
+              <a:t>24.01.2023</a:t>
             </a:fld>
             <a:endParaRPr lang="de-DE"/>
           </a:p>
@@ -1193,7 +1193,7 @@
           <a:p>
             <a:fld id="{95176C13-B2CD-406A-8CCB-6356FE93C9A4}" type="slidenum">
               <a:rPr lang="de-DE" smtClean="0"/>
-              <a:t>‹#›</a:t>
+              <a:t>‹Nr.›</a:t>
             </a:fld>
             <a:endParaRPr lang="de-DE"/>
           </a:p>
@@ -1404,7 +1404,7 @@
           <a:p>
             <a:fld id="{5C26CB86-9D02-4EAF-92D6-993F0AA89364}" type="datetimeFigureOut">
               <a:rPr lang="de-DE" smtClean="0"/>
-              <a:t>09.01.2023</a:t>
+              <a:t>24.01.2023</a:t>
             </a:fld>
             <a:endParaRPr lang="de-DE"/>
           </a:p>
@@ -1458,7 +1458,7 @@
           <a:p>
             <a:fld id="{95176C13-B2CD-406A-8CCB-6356FE93C9A4}" type="slidenum">
               <a:rPr lang="de-DE" smtClean="0"/>
-              <a:t>‹#›</a:t>
+              <a:t>‹Nr.›</a:t>
             </a:fld>
             <a:endParaRPr lang="de-DE"/>
           </a:p>
@@ -1816,7 +1816,7 @@
           <a:p>
             <a:fld id="{5C26CB86-9D02-4EAF-92D6-993F0AA89364}" type="datetimeFigureOut">
               <a:rPr lang="de-DE" smtClean="0"/>
-              <a:t>09.01.2023</a:t>
+              <a:t>24.01.2023</a:t>
             </a:fld>
             <a:endParaRPr lang="de-DE"/>
           </a:p>
@@ -1870,7 +1870,7 @@
           <a:p>
             <a:fld id="{95176C13-B2CD-406A-8CCB-6356FE93C9A4}" type="slidenum">
               <a:rPr lang="de-DE" smtClean="0"/>
-              <a:t>‹#›</a:t>
+              <a:t>‹Nr.›</a:t>
             </a:fld>
             <a:endParaRPr lang="de-DE"/>
           </a:p>
@@ -1957,7 +1957,7 @@
           <a:p>
             <a:fld id="{5C26CB86-9D02-4EAF-92D6-993F0AA89364}" type="datetimeFigureOut">
               <a:rPr lang="de-DE" smtClean="0"/>
-              <a:t>09.01.2023</a:t>
+              <a:t>24.01.2023</a:t>
             </a:fld>
             <a:endParaRPr lang="de-DE"/>
           </a:p>
@@ -2011,7 +2011,7 @@
           <a:p>
             <a:fld id="{95176C13-B2CD-406A-8CCB-6356FE93C9A4}" type="slidenum">
               <a:rPr lang="de-DE" smtClean="0"/>
-              <a:t>‹#›</a:t>
+              <a:t>‹Nr.›</a:t>
             </a:fld>
             <a:endParaRPr lang="de-DE"/>
           </a:p>
@@ -2070,7 +2070,7 @@
           <a:p>
             <a:fld id="{5C26CB86-9D02-4EAF-92D6-993F0AA89364}" type="datetimeFigureOut">
               <a:rPr lang="de-DE" smtClean="0"/>
-              <a:t>09.01.2023</a:t>
+              <a:t>24.01.2023</a:t>
             </a:fld>
             <a:endParaRPr lang="de-DE"/>
           </a:p>
@@ -2124,7 +2124,7 @@
           <a:p>
             <a:fld id="{95176C13-B2CD-406A-8CCB-6356FE93C9A4}" type="slidenum">
               <a:rPr lang="de-DE" smtClean="0"/>
-              <a:t>‹#›</a:t>
+              <a:t>‹Nr.›</a:t>
             </a:fld>
             <a:endParaRPr lang="de-DE"/>
           </a:p>
@@ -2381,7 +2381,7 @@
           <a:p>
             <a:fld id="{5C26CB86-9D02-4EAF-92D6-993F0AA89364}" type="datetimeFigureOut">
               <a:rPr lang="de-DE" smtClean="0"/>
-              <a:t>09.01.2023</a:t>
+              <a:t>24.01.2023</a:t>
             </a:fld>
             <a:endParaRPr lang="de-DE"/>
           </a:p>
@@ -2435,7 +2435,7 @@
           <a:p>
             <a:fld id="{95176C13-B2CD-406A-8CCB-6356FE93C9A4}" type="slidenum">
               <a:rPr lang="de-DE" smtClean="0"/>
-              <a:t>‹#›</a:t>
+              <a:t>‹Nr.›</a:t>
             </a:fld>
             <a:endParaRPr lang="de-DE"/>
           </a:p>
@@ -2669,7 +2669,7 @@
           <a:p>
             <a:fld id="{5C26CB86-9D02-4EAF-92D6-993F0AA89364}" type="datetimeFigureOut">
               <a:rPr lang="de-DE" smtClean="0"/>
-              <a:t>09.01.2023</a:t>
+              <a:t>24.01.2023</a:t>
             </a:fld>
             <a:endParaRPr lang="de-DE"/>
           </a:p>
@@ -2723,7 +2723,7 @@
           <a:p>
             <a:fld id="{95176C13-B2CD-406A-8CCB-6356FE93C9A4}" type="slidenum">
               <a:rPr lang="de-DE" smtClean="0"/>
-              <a:t>‹#›</a:t>
+              <a:t>‹Nr.›</a:t>
             </a:fld>
             <a:endParaRPr lang="de-DE"/>
           </a:p>
@@ -2910,7 +2910,7 @@
           <a:p>
             <a:fld id="{5C26CB86-9D02-4EAF-92D6-993F0AA89364}" type="datetimeFigureOut">
               <a:rPr lang="de-DE" smtClean="0"/>
-              <a:t>09.01.2023</a:t>
+              <a:t>24.01.2023</a:t>
             </a:fld>
             <a:endParaRPr lang="de-DE"/>
           </a:p>
@@ -3000,7 +3000,7 @@
           <a:p>
             <a:fld id="{95176C13-B2CD-406A-8CCB-6356FE93C9A4}" type="slidenum">
               <a:rPr lang="de-DE" smtClean="0"/>
-              <a:t>‹#›</a:t>
+              <a:t>‹Nr.›</a:t>
             </a:fld>
             <a:endParaRPr lang="de-DE"/>
           </a:p>
@@ -4774,7 +4774,7 @@
         </p:nvSpPr>
         <p:spPr>
           <a:xfrm>
-            <a:off x="2150397" y="3797639"/>
+            <a:off x="2180345" y="4661239"/>
             <a:ext cx="388452" cy="369330"/>
           </a:xfrm>
           <a:prstGeom prst="ellipse">
@@ -4829,7 +4829,7 @@
         </p:nvCxnSpPr>
         <p:spPr>
           <a:xfrm>
-            <a:off x="2207284" y="3851726"/>
+            <a:off x="2237232" y="4715326"/>
             <a:ext cx="274678" cy="261156"/>
           </a:xfrm>
           <a:prstGeom prst="line">
@@ -4873,7 +4873,7 @@
         </p:nvCxnSpPr>
         <p:spPr>
           <a:xfrm flipV="1">
-            <a:off x="2207284" y="3851726"/>
+            <a:off x="2237232" y="4715326"/>
             <a:ext cx="274678" cy="261156"/>
           </a:xfrm>
           <a:prstGeom prst="line">
@@ -4914,7 +4914,7 @@
         </p:nvSpPr>
         <p:spPr>
           <a:xfrm>
-            <a:off x="3210048" y="2553599"/>
+            <a:off x="2180345" y="1168292"/>
             <a:ext cx="388452" cy="369330"/>
           </a:xfrm>
           <a:prstGeom prst="ellipse">
@@ -4969,7 +4969,7 @@
         </p:nvCxnSpPr>
         <p:spPr>
           <a:xfrm>
-            <a:off x="3266935" y="2607686"/>
+            <a:off x="2237232" y="1222379"/>
             <a:ext cx="274678" cy="261156"/>
           </a:xfrm>
           <a:prstGeom prst="line">
@@ -5013,7 +5013,7 @@
         </p:nvCxnSpPr>
         <p:spPr>
           <a:xfrm flipV="1">
-            <a:off x="3266935" y="2607686"/>
+            <a:off x="2237232" y="1222379"/>
             <a:ext cx="274678" cy="261156"/>
           </a:xfrm>
           <a:prstGeom prst="line">
@@ -5054,7 +5054,7 @@
         </p:nvSpPr>
         <p:spPr>
           <a:xfrm>
-            <a:off x="6415616" y="3797639"/>
+            <a:off x="7346949" y="4661239"/>
             <a:ext cx="388452" cy="369330"/>
           </a:xfrm>
           <a:prstGeom prst="ellipse">
@@ -5109,7 +5109,7 @@
         </p:nvCxnSpPr>
         <p:spPr>
           <a:xfrm>
-            <a:off x="6472503" y="3851726"/>
+            <a:off x="7403836" y="4715326"/>
             <a:ext cx="274678" cy="261156"/>
           </a:xfrm>
           <a:prstGeom prst="line">
@@ -5153,7 +5153,7 @@
         </p:nvCxnSpPr>
         <p:spPr>
           <a:xfrm flipV="1">
-            <a:off x="6472503" y="3851726"/>
+            <a:off x="7403836" y="4715326"/>
             <a:ext cx="274678" cy="261156"/>
           </a:xfrm>
           <a:prstGeom prst="line">
@@ -5194,7 +5194,7 @@
         </p:nvSpPr>
         <p:spPr>
           <a:xfrm>
-            <a:off x="5080149" y="1651775"/>
+            <a:off x="7346949" y="1506539"/>
             <a:ext cx="388452" cy="369330"/>
           </a:xfrm>
           <a:prstGeom prst="ellipse">
@@ -5249,7 +5249,7 @@
         </p:nvCxnSpPr>
         <p:spPr>
           <a:xfrm>
-            <a:off x="5137036" y="1705862"/>
+            <a:off x="7403836" y="1560626"/>
             <a:ext cx="274678" cy="261156"/>
           </a:xfrm>
           <a:prstGeom prst="line">
@@ -5294,7 +5294,7 @@
         </p:nvCxnSpPr>
         <p:spPr>
           <a:xfrm flipV="1">
-            <a:off x="5137036" y="1705862"/>
+            <a:off x="7403836" y="1560626"/>
             <a:ext cx="274678" cy="261156"/>
           </a:xfrm>
           <a:prstGeom prst="line">
@@ -5304,96 +5304,6 @@
             <a:solidFill>
               <a:schemeClr val="tx1"/>
             </a:solidFill>
-          </a:ln>
-        </p:spPr>
-        <p:style>
-          <a:lnRef idx="1">
-            <a:schemeClr val="accent1"/>
-          </a:lnRef>
-          <a:fillRef idx="0">
-            <a:schemeClr val="accent1"/>
-          </a:fillRef>
-          <a:effectRef idx="0">
-            <a:schemeClr val="accent1"/>
-          </a:effectRef>
-          <a:fontRef idx="minor">
-            <a:schemeClr val="tx1"/>
-          </a:fontRef>
-        </p:style>
-      </p:cxnSp>
-      <p:cxnSp>
-        <p:nvCxnSpPr>
-          <p:cNvPr id="52" name="Gerade Verbindung mit Pfeil 1">
-            <a:extLst>
-              <a:ext uri="{FF2B5EF4-FFF2-40B4-BE49-F238E27FC236}">
-                <a16:creationId xmlns:a16="http://schemas.microsoft.com/office/drawing/2014/main" id="{FF93F02D-F8FD-3240-E5D2-C9E0599C8281}"/>
-              </a:ext>
-            </a:extLst>
-          </p:cNvPr>
-          <p:cNvCxnSpPr>
-            <a:cxnSpLocks/>
-          </p:cNvCxnSpPr>
-          <p:nvPr/>
-        </p:nvCxnSpPr>
-        <p:spPr>
-          <a:xfrm>
-            <a:off x="3434229" y="2948285"/>
-            <a:ext cx="1473051" cy="3048"/>
-          </a:xfrm>
-          <a:prstGeom prst="straightConnector1">
-            <a:avLst/>
-          </a:prstGeom>
-          <a:ln>
-            <a:solidFill>
-              <a:schemeClr val="tx1"/>
-            </a:solidFill>
-            <a:headEnd type="triangle"/>
-            <a:tailEnd type="triangle"/>
-          </a:ln>
-        </p:spPr>
-        <p:style>
-          <a:lnRef idx="1">
-            <a:schemeClr val="accent1"/>
-          </a:lnRef>
-          <a:fillRef idx="0">
-            <a:schemeClr val="accent1"/>
-          </a:fillRef>
-          <a:effectRef idx="0">
-            <a:schemeClr val="accent1"/>
-          </a:effectRef>
-          <a:fontRef idx="minor">
-            <a:schemeClr val="tx1"/>
-          </a:fontRef>
-        </p:style>
-      </p:cxnSp>
-      <p:cxnSp>
-        <p:nvCxnSpPr>
-          <p:cNvPr id="55" name="Gerade Verbindung mit Pfeil 1">
-            <a:extLst>
-              <a:ext uri="{FF2B5EF4-FFF2-40B4-BE49-F238E27FC236}">
-                <a16:creationId xmlns:a16="http://schemas.microsoft.com/office/drawing/2014/main" id="{C5069DEE-D624-E83C-3C41-84F215401D17}"/>
-              </a:ext>
-            </a:extLst>
-          </p:cNvPr>
-          <p:cNvCxnSpPr>
-            <a:cxnSpLocks/>
-          </p:cNvCxnSpPr>
-          <p:nvPr/>
-        </p:nvCxnSpPr>
-        <p:spPr>
-          <a:xfrm>
-            <a:off x="4975178" y="2334342"/>
-            <a:ext cx="228973" cy="10500"/>
-          </a:xfrm>
-          <a:prstGeom prst="straightConnector1">
-            <a:avLst/>
-          </a:prstGeom>
-          <a:ln>
-            <a:solidFill>
-              <a:schemeClr val="tx1"/>
-            </a:solidFill>
-            <a:headEnd type="triangle"/>
-            <a:tailEnd type="triangle"/>
           </a:ln>
         </p:spPr>
         <p:style>
@@ -5428,7 +5338,7 @@
         <p:spPr>
           <a:xfrm flipH="1">
             <a:off x="5009054" y="3978584"/>
-            <a:ext cx="1525096" cy="0"/>
+            <a:ext cx="2475479" cy="0"/>
           </a:xfrm>
           <a:prstGeom prst="straightConnector1">
             <a:avLst/>
@@ -5439,6 +5349,232 @@
             </a:solidFill>
             <a:headEnd type="triangle"/>
             <a:tailEnd type="triangle"/>
+          </a:ln>
+        </p:spPr>
+        <p:style>
+          <a:lnRef idx="1">
+            <a:schemeClr val="accent1"/>
+          </a:lnRef>
+          <a:fillRef idx="0">
+            <a:schemeClr val="accent1"/>
+          </a:fillRef>
+          <a:effectRef idx="0">
+            <a:schemeClr val="accent1"/>
+          </a:effectRef>
+          <a:fontRef idx="minor">
+            <a:schemeClr val="tx1"/>
+          </a:fontRef>
+        </p:style>
+      </p:cxnSp>
+      <p:sp>
+        <p:nvSpPr>
+          <p:cNvPr id="71" name="Textfeld 25">
+            <a:extLst>
+              <a:ext uri="{FF2B5EF4-FFF2-40B4-BE49-F238E27FC236}">
+                <a16:creationId xmlns:a16="http://schemas.microsoft.com/office/drawing/2014/main" id="{71633B82-979D-9563-54DB-8B521AD7C5E1}"/>
+              </a:ext>
+            </a:extLst>
+          </p:cNvPr>
+          <p:cNvSpPr txBox="1"/>
+          <p:nvPr/>
+        </p:nvSpPr>
+        <p:spPr>
+          <a:xfrm rot="16200000">
+            <a:off x="4069736" y="4627180"/>
+            <a:ext cx="1367278" cy="369332"/>
+          </a:xfrm>
+          <a:prstGeom prst="rect">
+            <a:avLst/>
+          </a:prstGeom>
+          <a:noFill/>
+        </p:spPr>
+        <p:txBody>
+          <a:bodyPr wrap="square" rtlCol="0">
+            <a:spAutoFit/>
+          </a:bodyPr>
+          <a:lstStyle/>
+          <a:p>
+            <a:pPr marL="0" marR="0" lvl="0" indent="0" algn="l" defTabSz="914400" rtl="0" eaLnBrk="1" fontAlgn="auto" latinLnBrk="0" hangingPunct="1">
+              <a:lnSpc>
+                <a:spcPct val="100000"/>
+              </a:lnSpc>
+              <a:spcBef>
+                <a:spcPts val="0"/>
+              </a:spcBef>
+              <a:spcAft>
+                <a:spcPts val="0"/>
+              </a:spcAft>
+              <a:buClrTx/>
+              <a:buSzTx/>
+              <a:buFontTx/>
+              <a:buNone/>
+              <a:tabLst/>
+              <a:defRPr/>
+            </a:pPr>
+            <a:r>
+              <a:rPr kumimoji="0" lang="de-DE" sz="1800" b="0" i="0" u="none" strike="noStrike" kern="1200" cap="none" spc="0" normalizeH="0" baseline="0" noProof="0" dirty="0">
+                <a:ln>
+                  <a:noFill/>
+                </a:ln>
+                <a:solidFill>
+                  <a:prstClr val="black"/>
+                </a:solidFill>
+                <a:effectLst/>
+                <a:uLnTx/>
+                <a:uFillTx/>
+                <a:latin typeface="Calibri" panose="020F0502020204030204"/>
+                <a:ea typeface="+mn-ea"/>
+                <a:cs typeface="+mn-cs"/>
+              </a:rPr>
+              <a:t>Ca. 20 mm</a:t>
+            </a:r>
+          </a:p>
+        </p:txBody>
+      </p:sp>
+      <p:sp>
+        <p:nvSpPr>
+          <p:cNvPr id="72" name="Textfeld 25">
+            <a:extLst>
+              <a:ext uri="{FF2B5EF4-FFF2-40B4-BE49-F238E27FC236}">
+                <a16:creationId xmlns:a16="http://schemas.microsoft.com/office/drawing/2014/main" id="{1847DD11-D27C-6734-769D-C70493D80873}"/>
+              </a:ext>
+            </a:extLst>
+          </p:cNvPr>
+          <p:cNvSpPr txBox="1"/>
+          <p:nvPr/>
+        </p:nvSpPr>
+        <p:spPr>
+          <a:xfrm>
+            <a:off x="5586082" y="4106972"/>
+            <a:ext cx="1367278" cy="369332"/>
+          </a:xfrm>
+          <a:prstGeom prst="rect">
+            <a:avLst/>
+          </a:prstGeom>
+          <a:noFill/>
+        </p:spPr>
+        <p:txBody>
+          <a:bodyPr wrap="square" rtlCol="0">
+            <a:spAutoFit/>
+          </a:bodyPr>
+          <a:lstStyle/>
+          <a:p>
+            <a:pPr marL="0" marR="0" lvl="0" indent="0" algn="l" defTabSz="914400" rtl="0" eaLnBrk="1" fontAlgn="auto" latinLnBrk="0" hangingPunct="1">
+              <a:lnSpc>
+                <a:spcPct val="100000"/>
+              </a:lnSpc>
+              <a:spcBef>
+                <a:spcPts val="0"/>
+              </a:spcBef>
+              <a:spcAft>
+                <a:spcPts val="0"/>
+              </a:spcAft>
+              <a:buClrTx/>
+              <a:buSzTx/>
+              <a:buFontTx/>
+              <a:buNone/>
+              <a:tabLst/>
+              <a:defRPr/>
+            </a:pPr>
+            <a:r>
+              <a:rPr kumimoji="0" lang="de-DE" sz="1800" b="0" i="0" u="none" strike="noStrike" kern="1200" cap="none" spc="0" normalizeH="0" baseline="0" noProof="0" dirty="0">
+                <a:ln>
+                  <a:noFill/>
+                </a:ln>
+                <a:solidFill>
+                  <a:prstClr val="black"/>
+                </a:solidFill>
+                <a:effectLst/>
+                <a:uLnTx/>
+                <a:uFillTx/>
+                <a:latin typeface="Calibri" panose="020F0502020204030204"/>
+                <a:ea typeface="+mn-ea"/>
+                <a:cs typeface="+mn-cs"/>
+              </a:rPr>
+              <a:t>Ca. 45 mm</a:t>
+            </a:r>
+          </a:p>
+        </p:txBody>
+      </p:sp>
+      <p:sp>
+        <p:nvSpPr>
+          <p:cNvPr id="73" name="Oval 72">
+            <a:extLst>
+              <a:ext uri="{FF2B5EF4-FFF2-40B4-BE49-F238E27FC236}">
+                <a16:creationId xmlns:a16="http://schemas.microsoft.com/office/drawing/2014/main" id="{33970B35-BF73-A093-E30D-B61BAFDC5A62}"/>
+              </a:ext>
+            </a:extLst>
+          </p:cNvPr>
+          <p:cNvSpPr/>
+          <p:nvPr/>
+        </p:nvSpPr>
+        <p:spPr>
+          <a:xfrm>
+            <a:off x="4757941" y="2556656"/>
+            <a:ext cx="388452" cy="369330"/>
+          </a:xfrm>
+          <a:prstGeom prst="ellipse">
+            <a:avLst/>
+          </a:prstGeom>
+          <a:noFill/>
+          <a:ln>
+            <a:solidFill>
+              <a:schemeClr val="tx1"/>
+            </a:solidFill>
+          </a:ln>
+        </p:spPr>
+        <p:style>
+          <a:lnRef idx="2">
+            <a:schemeClr val="accent1">
+              <a:shade val="50000"/>
+            </a:schemeClr>
+          </a:lnRef>
+          <a:fillRef idx="1">
+            <a:schemeClr val="accent1"/>
+          </a:fillRef>
+          <a:effectRef idx="0">
+            <a:schemeClr val="accent1"/>
+          </a:effectRef>
+          <a:fontRef idx="minor">
+            <a:schemeClr val="lt1"/>
+          </a:fontRef>
+        </p:style>
+        <p:txBody>
+          <a:bodyPr rtlCol="0" anchor="ctr"/>
+          <a:lstStyle/>
+          <a:p>
+            <a:pPr algn="ctr"/>
+            <a:endParaRPr lang="en-GB" dirty="0"/>
+          </a:p>
+        </p:txBody>
+      </p:sp>
+      <p:cxnSp>
+        <p:nvCxnSpPr>
+          <p:cNvPr id="74" name="Straight Connector 73">
+            <a:extLst>
+              <a:ext uri="{FF2B5EF4-FFF2-40B4-BE49-F238E27FC236}">
+                <a16:creationId xmlns:a16="http://schemas.microsoft.com/office/drawing/2014/main" id="{E595AB2C-EF68-4851-0471-72F5DD48654D}"/>
+              </a:ext>
+            </a:extLst>
+          </p:cNvPr>
+          <p:cNvCxnSpPr>
+            <a:stCxn id="73" idx="1"/>
+            <a:endCxn id="73" idx="5"/>
+          </p:cNvCxnSpPr>
+          <p:nvPr/>
+        </p:nvCxnSpPr>
+        <p:spPr>
+          <a:xfrm>
+            <a:off x="4814828" y="2610743"/>
+            <a:ext cx="274678" cy="261156"/>
+          </a:xfrm>
+          <a:prstGeom prst="line">
+            <a:avLst/>
+          </a:prstGeom>
+          <a:ln>
+            <a:solidFill>
+              <a:schemeClr val="tx1"/>
+            </a:solidFill>
           </a:ln>
         </p:spPr>
         <p:style>
@@ -5458,10 +5594,194 @@
       </p:cxnSp>
       <p:cxnSp>
         <p:nvCxnSpPr>
-          <p:cNvPr id="68" name="Gerade Verbindung mit Pfeil 7">
-            <a:extLst>
-              <a:ext uri="{FF2B5EF4-FFF2-40B4-BE49-F238E27FC236}">
-                <a16:creationId xmlns:a16="http://schemas.microsoft.com/office/drawing/2014/main" id="{51C76E73-E726-2D39-D471-26A80BE01062}"/>
+          <p:cNvPr id="75" name="Straight Connector 74">
+            <a:extLst>
+              <a:ext uri="{FF2B5EF4-FFF2-40B4-BE49-F238E27FC236}">
+                <a16:creationId xmlns:a16="http://schemas.microsoft.com/office/drawing/2014/main" id="{C78B94A1-B877-EDA1-FAB2-905F888D0391}"/>
+              </a:ext>
+            </a:extLst>
+          </p:cNvPr>
+          <p:cNvCxnSpPr>
+            <a:stCxn id="73" idx="3"/>
+            <a:endCxn id="73" idx="7"/>
+          </p:cNvCxnSpPr>
+          <p:nvPr/>
+        </p:nvCxnSpPr>
+        <p:spPr>
+          <a:xfrm flipV="1">
+            <a:off x="4814828" y="2610743"/>
+            <a:ext cx="274678" cy="261156"/>
+          </a:xfrm>
+          <a:prstGeom prst="line">
+            <a:avLst/>
+          </a:prstGeom>
+          <a:ln>
+            <a:solidFill>
+              <a:schemeClr val="tx1"/>
+            </a:solidFill>
+          </a:ln>
+        </p:spPr>
+        <p:style>
+          <a:lnRef idx="1">
+            <a:schemeClr val="accent1"/>
+          </a:lnRef>
+          <a:fillRef idx="0">
+            <a:schemeClr val="accent1"/>
+          </a:fillRef>
+          <a:effectRef idx="0">
+            <a:schemeClr val="accent1"/>
+          </a:effectRef>
+          <a:fontRef idx="minor">
+            <a:schemeClr val="tx1"/>
+          </a:fontRef>
+        </p:style>
+      </p:cxnSp>
+      <p:sp>
+        <p:nvSpPr>
+          <p:cNvPr id="76" name="Oval 75">
+            <a:extLst>
+              <a:ext uri="{FF2B5EF4-FFF2-40B4-BE49-F238E27FC236}">
+                <a16:creationId xmlns:a16="http://schemas.microsoft.com/office/drawing/2014/main" id="{AD9B8ACE-4E6B-8F6F-45A3-2816550B8966}"/>
+              </a:ext>
+            </a:extLst>
+          </p:cNvPr>
+          <p:cNvSpPr/>
+          <p:nvPr/>
+        </p:nvSpPr>
+        <p:spPr>
+          <a:xfrm>
+            <a:off x="4780952" y="3797639"/>
+            <a:ext cx="388452" cy="369330"/>
+          </a:xfrm>
+          <a:prstGeom prst="ellipse">
+            <a:avLst/>
+          </a:prstGeom>
+          <a:noFill/>
+          <a:ln>
+            <a:solidFill>
+              <a:schemeClr val="tx1"/>
+            </a:solidFill>
+          </a:ln>
+        </p:spPr>
+        <p:style>
+          <a:lnRef idx="2">
+            <a:schemeClr val="accent1">
+              <a:shade val="50000"/>
+            </a:schemeClr>
+          </a:lnRef>
+          <a:fillRef idx="1">
+            <a:schemeClr val="accent1"/>
+          </a:fillRef>
+          <a:effectRef idx="0">
+            <a:schemeClr val="accent1"/>
+          </a:effectRef>
+          <a:fontRef idx="minor">
+            <a:schemeClr val="lt1"/>
+          </a:fontRef>
+        </p:style>
+        <p:txBody>
+          <a:bodyPr rtlCol="0" anchor="ctr"/>
+          <a:lstStyle/>
+          <a:p>
+            <a:pPr algn="ctr"/>
+            <a:endParaRPr lang="en-GB" dirty="0"/>
+          </a:p>
+        </p:txBody>
+      </p:sp>
+      <p:cxnSp>
+        <p:nvCxnSpPr>
+          <p:cNvPr id="77" name="Straight Connector 76">
+            <a:extLst>
+              <a:ext uri="{FF2B5EF4-FFF2-40B4-BE49-F238E27FC236}">
+                <a16:creationId xmlns:a16="http://schemas.microsoft.com/office/drawing/2014/main" id="{C143756B-29C3-4957-44B1-D90E58C1674E}"/>
+              </a:ext>
+            </a:extLst>
+          </p:cNvPr>
+          <p:cNvCxnSpPr>
+            <a:stCxn id="76" idx="1"/>
+            <a:endCxn id="76" idx="5"/>
+          </p:cNvCxnSpPr>
+          <p:nvPr/>
+        </p:nvCxnSpPr>
+        <p:spPr>
+          <a:xfrm>
+            <a:off x="4837839" y="3851726"/>
+            <a:ext cx="274678" cy="261156"/>
+          </a:xfrm>
+          <a:prstGeom prst="line">
+            <a:avLst/>
+          </a:prstGeom>
+          <a:ln>
+            <a:solidFill>
+              <a:schemeClr val="tx1"/>
+            </a:solidFill>
+          </a:ln>
+        </p:spPr>
+        <p:style>
+          <a:lnRef idx="1">
+            <a:schemeClr val="accent1"/>
+          </a:lnRef>
+          <a:fillRef idx="0">
+            <a:schemeClr val="accent1"/>
+          </a:fillRef>
+          <a:effectRef idx="0">
+            <a:schemeClr val="accent1"/>
+          </a:effectRef>
+          <a:fontRef idx="minor">
+            <a:schemeClr val="tx1"/>
+          </a:fontRef>
+        </p:style>
+      </p:cxnSp>
+      <p:cxnSp>
+        <p:nvCxnSpPr>
+          <p:cNvPr id="78" name="Straight Connector 77">
+            <a:extLst>
+              <a:ext uri="{FF2B5EF4-FFF2-40B4-BE49-F238E27FC236}">
+                <a16:creationId xmlns:a16="http://schemas.microsoft.com/office/drawing/2014/main" id="{D4DB9B87-9ED0-2673-679B-7F56385667B2}"/>
+              </a:ext>
+            </a:extLst>
+          </p:cNvPr>
+          <p:cNvCxnSpPr>
+            <a:stCxn id="76" idx="3"/>
+            <a:endCxn id="76" idx="7"/>
+          </p:cNvCxnSpPr>
+          <p:nvPr/>
+        </p:nvCxnSpPr>
+        <p:spPr>
+          <a:xfrm flipV="1">
+            <a:off x="4837839" y="3851726"/>
+            <a:ext cx="274678" cy="261156"/>
+          </a:xfrm>
+          <a:prstGeom prst="line">
+            <a:avLst/>
+          </a:prstGeom>
+          <a:ln>
+            <a:solidFill>
+              <a:schemeClr val="tx1"/>
+            </a:solidFill>
+          </a:ln>
+        </p:spPr>
+        <p:style>
+          <a:lnRef idx="1">
+            <a:schemeClr val="accent1"/>
+          </a:lnRef>
+          <a:fillRef idx="0">
+            <a:schemeClr val="accent1"/>
+          </a:fillRef>
+          <a:effectRef idx="0">
+            <a:schemeClr val="accent1"/>
+          </a:effectRef>
+          <a:fontRef idx="minor">
+            <a:schemeClr val="tx1"/>
+          </a:fontRef>
+        </p:style>
+      </p:cxnSp>
+      <p:cxnSp>
+        <p:nvCxnSpPr>
+          <p:cNvPr id="79" name="Gerade Verbindung mit Pfeil 1">
+            <a:extLst>
+              <a:ext uri="{FF2B5EF4-FFF2-40B4-BE49-F238E27FC236}">
+                <a16:creationId xmlns:a16="http://schemas.microsoft.com/office/drawing/2014/main" id="{C38B4B24-2416-42F0-B8C4-6EACDE4D9DF8}"/>
               </a:ext>
             </a:extLst>
           </p:cNvPr>
@@ -5471,9 +5791,9 @@
           <p:nvPr/>
         </p:nvCxnSpPr>
         <p:spPr>
-          <a:xfrm flipV="1">
-            <a:off x="4965700" y="1762261"/>
-            <a:ext cx="0" cy="794395"/>
+          <a:xfrm>
+            <a:off x="2374571" y="3978584"/>
+            <a:ext cx="2577596" cy="5063"/>
           </a:xfrm>
           <a:prstGeom prst="straightConnector1">
             <a:avLst/>
@@ -5503,10 +5823,10 @@
       </p:cxnSp>
       <p:sp>
         <p:nvSpPr>
-          <p:cNvPr id="69" name="Textfeld 25">
-            <a:extLst>
-              <a:ext uri="{FF2B5EF4-FFF2-40B4-BE49-F238E27FC236}">
-                <a16:creationId xmlns:a16="http://schemas.microsoft.com/office/drawing/2014/main" id="{5419F6C9-1734-53CC-3395-4AA587F01E98}"/>
+          <p:cNvPr id="83" name="Textfeld 25">
+            <a:extLst>
+              <a:ext uri="{FF2B5EF4-FFF2-40B4-BE49-F238E27FC236}">
+                <a16:creationId xmlns:a16="http://schemas.microsoft.com/office/drawing/2014/main" id="{0A625F1F-569F-6347-6745-47AE2B9DEF10}"/>
               </a:ext>
             </a:extLst>
           </p:cNvPr>
@@ -5515,7 +5835,7 @@
         </p:nvSpPr>
         <p:spPr>
           <a:xfrm>
-            <a:off x="3241326" y="2998086"/>
+            <a:off x="3179701" y="4024914"/>
             <a:ext cx="1367278" cy="369332"/>
           </a:xfrm>
           <a:prstGeom prst="rect">
@@ -5570,7 +5890,7 @@
                 </a:solidFill>
                 <a:latin typeface="Calibri" panose="020F0502020204030204"/>
               </a:rPr>
-              <a:t>26.7</a:t>
+              <a:t>30</a:t>
             </a:r>
             <a:r>
               <a:rPr kumimoji="0" lang="de-DE" sz="1800" b="0" i="0" u="none" strike="noStrike" kern="1200" cap="none" spc="0" normalizeH="0" baseline="0" noProof="0" dirty="0">
@@ -5592,12 +5912,57 @@
           </a:p>
         </p:txBody>
       </p:sp>
-      <p:sp>
-        <p:nvSpPr>
-          <p:cNvPr id="70" name="Textfeld 25">
-            <a:extLst>
-              <a:ext uri="{FF2B5EF4-FFF2-40B4-BE49-F238E27FC236}">
-                <a16:creationId xmlns:a16="http://schemas.microsoft.com/office/drawing/2014/main" id="{14A01BA8-C0D7-DF0D-EA9F-BB5637C84581}"/>
+      <p:cxnSp>
+        <p:nvCxnSpPr>
+          <p:cNvPr id="84" name="Gerade Verbindung mit Pfeil 7">
+            <a:extLst>
+              <a:ext uri="{FF2B5EF4-FFF2-40B4-BE49-F238E27FC236}">
+                <a16:creationId xmlns:a16="http://schemas.microsoft.com/office/drawing/2014/main" id="{6779554B-F03F-6430-B4A4-AE19C4CB3D59}"/>
+              </a:ext>
+            </a:extLst>
+          </p:cNvPr>
+          <p:cNvCxnSpPr>
+            <a:cxnSpLocks/>
+          </p:cNvCxnSpPr>
+          <p:nvPr/>
+        </p:nvCxnSpPr>
+        <p:spPr>
+          <a:xfrm flipV="1">
+            <a:off x="5318449" y="2770286"/>
+            <a:ext cx="0" cy="1178949"/>
+          </a:xfrm>
+          <a:prstGeom prst="straightConnector1">
+            <a:avLst/>
+          </a:prstGeom>
+          <a:ln>
+            <a:solidFill>
+              <a:schemeClr val="tx1"/>
+            </a:solidFill>
+            <a:headEnd type="triangle"/>
+            <a:tailEnd type="triangle"/>
+          </a:ln>
+        </p:spPr>
+        <p:style>
+          <a:lnRef idx="1">
+            <a:schemeClr val="accent1"/>
+          </a:lnRef>
+          <a:fillRef idx="0">
+            <a:schemeClr val="accent1"/>
+          </a:fillRef>
+          <a:effectRef idx="0">
+            <a:schemeClr val="accent1"/>
+          </a:effectRef>
+          <a:fontRef idx="minor">
+            <a:schemeClr val="tx1"/>
+          </a:fontRef>
+        </p:style>
+      </p:cxnSp>
+      <p:sp>
+        <p:nvSpPr>
+          <p:cNvPr id="85" name="Textfeld 25">
+            <a:extLst>
+              <a:ext uri="{FF2B5EF4-FFF2-40B4-BE49-F238E27FC236}">
+                <a16:creationId xmlns:a16="http://schemas.microsoft.com/office/drawing/2014/main" id="{76BE0EAB-65F7-C720-DF48-9A726E02041F}"/>
               </a:ext>
             </a:extLst>
           </p:cNvPr>
@@ -5605,8 +5970,8 @@
           <p:nvPr/>
         </p:nvSpPr>
         <p:spPr>
-          <a:xfrm>
-            <a:off x="5024149" y="2046060"/>
+          <a:xfrm rot="16200000">
+            <a:off x="4899740" y="3110279"/>
             <a:ext cx="1367278" cy="369332"/>
           </a:xfrm>
           <a:prstGeom prst="rect">
@@ -5652,17 +6017,17 @@
                 <a:ea typeface="+mn-ea"/>
                 <a:cs typeface="+mn-cs"/>
               </a:rPr>
-              <a:t>Ca. 3.3 mm</a:t>
-            </a:r>
-          </a:p>
-        </p:txBody>
-      </p:sp>
-      <p:sp>
-        <p:nvSpPr>
-          <p:cNvPr id="71" name="Textfeld 25">
-            <a:extLst>
-              <a:ext uri="{FF2B5EF4-FFF2-40B4-BE49-F238E27FC236}">
-                <a16:creationId xmlns:a16="http://schemas.microsoft.com/office/drawing/2014/main" id="{71633B82-979D-9563-54DB-8B521AD7C5E1}"/>
+              <a:t>Ca. 33.5 mm</a:t>
+            </a:r>
+          </a:p>
+        </p:txBody>
+      </p:sp>
+      <p:sp>
+        <p:nvSpPr>
+          <p:cNvPr id="3" name="TextBox 2">
+            <a:extLst>
+              <a:ext uri="{FF2B5EF4-FFF2-40B4-BE49-F238E27FC236}">
+                <a16:creationId xmlns:a16="http://schemas.microsoft.com/office/drawing/2014/main" id="{954C7D5E-2207-47CF-B55D-A56E1F5C694E}"/>
               </a:ext>
             </a:extLst>
           </p:cNvPr>
@@ -5670,8 +6035,89 @@
           <p:nvPr/>
         </p:nvSpPr>
         <p:spPr>
+          <a:xfrm>
+            <a:off x="684848" y="367282"/>
+            <a:ext cx="3072316" cy="461665"/>
+          </a:xfrm>
+          <a:prstGeom prst="rect">
+            <a:avLst/>
+          </a:prstGeom>
+          <a:noFill/>
+        </p:spPr>
+        <p:txBody>
+          <a:bodyPr wrap="none" rtlCol="0">
+            <a:spAutoFit/>
+          </a:bodyPr>
+          <a:lstStyle/>
+          <a:p>
+            <a:r>
+              <a:rPr lang="de-DE" sz="2400" b="1" dirty="0"/>
+              <a:t>Kühlkörper Bohrungen</a:t>
+            </a:r>
+            <a:endParaRPr lang="en-GB" sz="2400" b="1" dirty="0"/>
+          </a:p>
+        </p:txBody>
+      </p:sp>
+      <p:cxnSp>
+        <p:nvCxnSpPr>
+          <p:cNvPr id="4" name="Gerade Verbindung mit Pfeil 7">
+            <a:extLst>
+              <a:ext uri="{FF2B5EF4-FFF2-40B4-BE49-F238E27FC236}">
+                <a16:creationId xmlns:a16="http://schemas.microsoft.com/office/drawing/2014/main" id="{25B76836-199C-E24D-38BA-8A5CF83EF401}"/>
+              </a:ext>
+            </a:extLst>
+          </p:cNvPr>
+          <p:cNvCxnSpPr>
+            <a:cxnSpLocks/>
+          </p:cNvCxnSpPr>
+          <p:nvPr/>
+        </p:nvCxnSpPr>
+        <p:spPr>
+          <a:xfrm flipH="1" flipV="1">
+            <a:off x="4994516" y="3997048"/>
+            <a:ext cx="14538" cy="1159152"/>
+          </a:xfrm>
+          <a:prstGeom prst="straightConnector1">
+            <a:avLst/>
+          </a:prstGeom>
+          <a:ln>
+            <a:solidFill>
+              <a:schemeClr val="tx1"/>
+            </a:solidFill>
+            <a:headEnd type="triangle"/>
+            <a:tailEnd type="triangle"/>
+          </a:ln>
+        </p:spPr>
+        <p:style>
+          <a:lnRef idx="1">
+            <a:schemeClr val="accent1"/>
+          </a:lnRef>
+          <a:fillRef idx="0">
+            <a:schemeClr val="accent1"/>
+          </a:fillRef>
+          <a:effectRef idx="0">
+            <a:schemeClr val="accent1"/>
+          </a:effectRef>
+          <a:fontRef idx="minor">
+            <a:schemeClr val="tx1"/>
+          </a:fontRef>
+        </p:style>
+      </p:cxnSp>
+      <p:sp>
+        <p:nvSpPr>
+          <p:cNvPr id="7" name="Textfeld 25">
+            <a:extLst>
+              <a:ext uri="{FF2B5EF4-FFF2-40B4-BE49-F238E27FC236}">
+                <a16:creationId xmlns:a16="http://schemas.microsoft.com/office/drawing/2014/main" id="{58383F55-D652-87A6-1AF8-BD5A6DFF39F1}"/>
+              </a:ext>
+            </a:extLst>
+          </p:cNvPr>
+          <p:cNvSpPr txBox="1"/>
+          <p:nvPr/>
+        </p:nvSpPr>
+        <p:spPr>
           <a:xfrm rot="16200000">
-            <a:off x="3969534" y="1721352"/>
+            <a:off x="5336726" y="1913220"/>
             <a:ext cx="1367278" cy="369332"/>
           </a:xfrm>
           <a:prstGeom prst="rect">
@@ -5717,7 +6163,117 @@
                 <a:ea typeface="+mn-ea"/>
                 <a:cs typeface="+mn-cs"/>
               </a:rPr>
-              <a:t>Ca. </a:t>
+              <a:t>Ca. 20 mm</a:t>
+            </a:r>
+          </a:p>
+        </p:txBody>
+      </p:sp>
+      <p:cxnSp>
+        <p:nvCxnSpPr>
+          <p:cNvPr id="11" name="Gerade Verbindung mit Pfeil 7">
+            <a:extLst>
+              <a:ext uri="{FF2B5EF4-FFF2-40B4-BE49-F238E27FC236}">
+                <a16:creationId xmlns:a16="http://schemas.microsoft.com/office/drawing/2014/main" id="{1D966112-9A87-238B-DE57-18AF52EF1FC2}"/>
+              </a:ext>
+            </a:extLst>
+          </p:cNvPr>
+          <p:cNvCxnSpPr>
+            <a:cxnSpLocks/>
+          </p:cNvCxnSpPr>
+          <p:nvPr/>
+        </p:nvCxnSpPr>
+        <p:spPr>
+          <a:xfrm flipV="1">
+            <a:off x="5742617" y="1821782"/>
+            <a:ext cx="0" cy="919539"/>
+          </a:xfrm>
+          <a:prstGeom prst="straightConnector1">
+            <a:avLst/>
+          </a:prstGeom>
+          <a:ln>
+            <a:solidFill>
+              <a:schemeClr val="tx1"/>
+            </a:solidFill>
+            <a:headEnd type="triangle"/>
+            <a:tailEnd type="triangle"/>
+          </a:ln>
+        </p:spPr>
+        <p:style>
+          <a:lnRef idx="1">
+            <a:schemeClr val="accent1"/>
+          </a:lnRef>
+          <a:fillRef idx="0">
+            <a:schemeClr val="accent1"/>
+          </a:fillRef>
+          <a:effectRef idx="0">
+            <a:schemeClr val="accent1"/>
+          </a:effectRef>
+          <a:fontRef idx="minor">
+            <a:schemeClr val="tx1"/>
+          </a:fontRef>
+        </p:style>
+      </p:cxnSp>
+      <p:sp>
+        <p:nvSpPr>
+          <p:cNvPr id="13" name="Textfeld 25">
+            <a:extLst>
+              <a:ext uri="{FF2B5EF4-FFF2-40B4-BE49-F238E27FC236}">
+                <a16:creationId xmlns:a16="http://schemas.microsoft.com/office/drawing/2014/main" id="{A536B840-31A3-1DD0-EB88-F205F6B84AE3}"/>
+              </a:ext>
+            </a:extLst>
+          </p:cNvPr>
+          <p:cNvSpPr txBox="1"/>
+          <p:nvPr/>
+        </p:nvSpPr>
+        <p:spPr>
+          <a:xfrm rot="16200000">
+            <a:off x="3578810" y="1873016"/>
+            <a:ext cx="1367278" cy="369332"/>
+          </a:xfrm>
+          <a:prstGeom prst="rect">
+            <a:avLst/>
+          </a:prstGeom>
+          <a:noFill/>
+        </p:spPr>
+        <p:txBody>
+          <a:bodyPr wrap="square" rtlCol="0">
+            <a:spAutoFit/>
+          </a:bodyPr>
+          <a:lstStyle/>
+          <a:p>
+            <a:pPr marL="0" marR="0" lvl="0" indent="0" algn="l" defTabSz="914400" rtl="0" eaLnBrk="1" fontAlgn="auto" latinLnBrk="0" hangingPunct="1">
+              <a:lnSpc>
+                <a:spcPct val="100000"/>
+              </a:lnSpc>
+              <a:spcBef>
+                <a:spcPts val="0"/>
+              </a:spcBef>
+              <a:spcAft>
+                <a:spcPts val="0"/>
+              </a:spcAft>
+              <a:buClrTx/>
+              <a:buSzTx/>
+              <a:buFontTx/>
+              <a:buNone/>
+              <a:tabLst/>
+              <a:defRPr/>
+            </a:pPr>
+            <a:r>
+              <a:rPr kumimoji="0" lang="de-DE" sz="1800" b="0" i="0" u="none" strike="noStrike" kern="1200" cap="none" spc="0" normalizeH="0" baseline="0" noProof="0" dirty="0">
+                <a:ln>
+                  <a:noFill/>
+                </a:ln>
+                <a:solidFill>
+                  <a:prstClr val="black"/>
+                </a:solidFill>
+                <a:effectLst/>
+                <a:uLnTx/>
+                <a:uFillTx/>
+                <a:latin typeface="Calibri" panose="020F0502020204030204"/>
+                <a:ea typeface="+mn-ea"/>
+                <a:cs typeface="+mn-cs"/>
+              </a:rPr>
+              <a:t>Ca. 2</a:t>
             </a:r>
             <a:r>
               <a:rPr lang="de-DE" dirty="0">
@@ -5726,7 +6282,7 @@
                 </a:solidFill>
                 <a:latin typeface="Calibri" panose="020F0502020204030204"/>
               </a:rPr>
-              <a:t>14.5</a:t>
+              <a:t>5</a:t>
             </a:r>
             <a:r>
               <a:rPr kumimoji="0" lang="de-DE" sz="1800" b="0" i="0" u="none" strike="noStrike" kern="1200" cap="none" spc="0" normalizeH="0" baseline="0" noProof="0" dirty="0">
@@ -5748,383 +6304,12 @@
           </a:p>
         </p:txBody>
       </p:sp>
-      <p:sp>
-        <p:nvSpPr>
-          <p:cNvPr id="72" name="Textfeld 25">
-            <a:extLst>
-              <a:ext uri="{FF2B5EF4-FFF2-40B4-BE49-F238E27FC236}">
-                <a16:creationId xmlns:a16="http://schemas.microsoft.com/office/drawing/2014/main" id="{1847DD11-D27C-6734-769D-C70493D80873}"/>
-              </a:ext>
-            </a:extLst>
-          </p:cNvPr>
-          <p:cNvSpPr txBox="1"/>
-          <p:nvPr/>
-        </p:nvSpPr>
-        <p:spPr>
-          <a:xfrm>
-            <a:off x="5146393" y="4092852"/>
-            <a:ext cx="1367278" cy="369332"/>
-          </a:xfrm>
-          <a:prstGeom prst="rect">
-            <a:avLst/>
-          </a:prstGeom>
-          <a:noFill/>
-        </p:spPr>
-        <p:txBody>
-          <a:bodyPr wrap="square" rtlCol="0">
-            <a:spAutoFit/>
-          </a:bodyPr>
-          <a:lstStyle/>
-          <a:p>
-            <a:pPr marL="0" marR="0" lvl="0" indent="0" algn="l" defTabSz="914400" rtl="0" eaLnBrk="1" fontAlgn="auto" latinLnBrk="0" hangingPunct="1">
-              <a:lnSpc>
-                <a:spcPct val="100000"/>
-              </a:lnSpc>
-              <a:spcBef>
-                <a:spcPts val="0"/>
-              </a:spcBef>
-              <a:spcAft>
-                <a:spcPts val="0"/>
-              </a:spcAft>
-              <a:buClrTx/>
-              <a:buSzTx/>
-              <a:buFontTx/>
-              <a:buNone/>
-              <a:tabLst/>
-              <a:defRPr/>
-            </a:pPr>
-            <a:r>
-              <a:rPr kumimoji="0" lang="de-DE" sz="1800" b="0" i="0" u="none" strike="noStrike" kern="1200" cap="none" spc="0" normalizeH="0" baseline="0" noProof="0" dirty="0">
-                <a:ln>
-                  <a:noFill/>
-                </a:ln>
-                <a:solidFill>
-                  <a:prstClr val="black"/>
-                </a:solidFill>
-                <a:effectLst/>
-                <a:uLnTx/>
-                <a:uFillTx/>
-                <a:latin typeface="Calibri" panose="020F0502020204030204"/>
-                <a:ea typeface="+mn-ea"/>
-                <a:cs typeface="+mn-cs"/>
-              </a:rPr>
-              <a:t>Ca. </a:t>
-            </a:r>
-            <a:r>
-              <a:rPr lang="de-DE" dirty="0">
-                <a:solidFill>
-                  <a:prstClr val="black"/>
-                </a:solidFill>
-                <a:latin typeface="Calibri" panose="020F0502020204030204"/>
-              </a:rPr>
-              <a:t>31.3</a:t>
-            </a:r>
-            <a:r>
-              <a:rPr kumimoji="0" lang="de-DE" sz="1800" b="0" i="0" u="none" strike="noStrike" kern="1200" cap="none" spc="0" normalizeH="0" baseline="0" noProof="0" dirty="0">
-                <a:ln>
-                  <a:noFill/>
-                </a:ln>
-                <a:solidFill>
-                  <a:prstClr val="black"/>
-                </a:solidFill>
-                <a:effectLst/>
-                <a:uLnTx/>
-                <a:uFillTx/>
-                <a:latin typeface="Calibri" panose="020F0502020204030204"/>
-                <a:ea typeface="+mn-ea"/>
-                <a:cs typeface="+mn-cs"/>
-              </a:rPr>
-              <a:t> mm</a:t>
-            </a:r>
-          </a:p>
-        </p:txBody>
-      </p:sp>
-      <p:sp>
-        <p:nvSpPr>
-          <p:cNvPr id="73" name="Oval 72">
-            <a:extLst>
-              <a:ext uri="{FF2B5EF4-FFF2-40B4-BE49-F238E27FC236}">
-                <a16:creationId xmlns:a16="http://schemas.microsoft.com/office/drawing/2014/main" id="{33970B35-BF73-A093-E30D-B61BAFDC5A62}"/>
-              </a:ext>
-            </a:extLst>
-          </p:cNvPr>
-          <p:cNvSpPr/>
-          <p:nvPr/>
-        </p:nvSpPr>
-        <p:spPr>
-          <a:xfrm>
-            <a:off x="4757941" y="2556656"/>
-            <a:ext cx="388452" cy="369330"/>
-          </a:xfrm>
-          <a:prstGeom prst="ellipse">
-            <a:avLst/>
-          </a:prstGeom>
-          <a:noFill/>
-          <a:ln>
-            <a:solidFill>
-              <a:schemeClr val="tx1"/>
-            </a:solidFill>
-          </a:ln>
-        </p:spPr>
-        <p:style>
-          <a:lnRef idx="2">
-            <a:schemeClr val="accent1">
-              <a:shade val="50000"/>
-            </a:schemeClr>
-          </a:lnRef>
-          <a:fillRef idx="1">
-            <a:schemeClr val="accent1"/>
-          </a:fillRef>
-          <a:effectRef idx="0">
-            <a:schemeClr val="accent1"/>
-          </a:effectRef>
-          <a:fontRef idx="minor">
-            <a:schemeClr val="lt1"/>
-          </a:fontRef>
-        </p:style>
-        <p:txBody>
-          <a:bodyPr rtlCol="0" anchor="ctr"/>
-          <a:lstStyle/>
-          <a:p>
-            <a:pPr algn="ctr"/>
-            <a:endParaRPr lang="en-GB" dirty="0"/>
-          </a:p>
-        </p:txBody>
-      </p:sp>
       <p:cxnSp>
         <p:nvCxnSpPr>
-          <p:cNvPr id="74" name="Straight Connector 73">
-            <a:extLst>
-              <a:ext uri="{FF2B5EF4-FFF2-40B4-BE49-F238E27FC236}">
-                <a16:creationId xmlns:a16="http://schemas.microsoft.com/office/drawing/2014/main" id="{E595AB2C-EF68-4851-0471-72F5DD48654D}"/>
-              </a:ext>
-            </a:extLst>
-          </p:cNvPr>
-          <p:cNvCxnSpPr>
-            <a:stCxn id="73" idx="1"/>
-            <a:endCxn id="73" idx="5"/>
-          </p:cNvCxnSpPr>
-          <p:nvPr/>
-        </p:nvCxnSpPr>
-        <p:spPr>
-          <a:xfrm>
-            <a:off x="4814828" y="2610743"/>
-            <a:ext cx="274678" cy="261156"/>
-          </a:xfrm>
-          <a:prstGeom prst="line">
-            <a:avLst/>
-          </a:prstGeom>
-          <a:ln>
-            <a:solidFill>
-              <a:schemeClr val="tx1"/>
-            </a:solidFill>
-          </a:ln>
-        </p:spPr>
-        <p:style>
-          <a:lnRef idx="1">
-            <a:schemeClr val="accent1"/>
-          </a:lnRef>
-          <a:fillRef idx="0">
-            <a:schemeClr val="accent1"/>
-          </a:fillRef>
-          <a:effectRef idx="0">
-            <a:schemeClr val="accent1"/>
-          </a:effectRef>
-          <a:fontRef idx="minor">
-            <a:schemeClr val="tx1"/>
-          </a:fontRef>
-        </p:style>
-      </p:cxnSp>
-      <p:cxnSp>
-        <p:nvCxnSpPr>
-          <p:cNvPr id="75" name="Straight Connector 74">
-            <a:extLst>
-              <a:ext uri="{FF2B5EF4-FFF2-40B4-BE49-F238E27FC236}">
-                <a16:creationId xmlns:a16="http://schemas.microsoft.com/office/drawing/2014/main" id="{C78B94A1-B877-EDA1-FAB2-905F888D0391}"/>
-              </a:ext>
-            </a:extLst>
-          </p:cNvPr>
-          <p:cNvCxnSpPr>
-            <a:stCxn id="73" idx="3"/>
-            <a:endCxn id="73" idx="7"/>
-          </p:cNvCxnSpPr>
-          <p:nvPr/>
-        </p:nvCxnSpPr>
-        <p:spPr>
-          <a:xfrm flipV="1">
-            <a:off x="4814828" y="2610743"/>
-            <a:ext cx="274678" cy="261156"/>
-          </a:xfrm>
-          <a:prstGeom prst="line">
-            <a:avLst/>
-          </a:prstGeom>
-          <a:ln>
-            <a:solidFill>
-              <a:schemeClr val="tx1"/>
-            </a:solidFill>
-          </a:ln>
-        </p:spPr>
-        <p:style>
-          <a:lnRef idx="1">
-            <a:schemeClr val="accent1"/>
-          </a:lnRef>
-          <a:fillRef idx="0">
-            <a:schemeClr val="accent1"/>
-          </a:fillRef>
-          <a:effectRef idx="0">
-            <a:schemeClr val="accent1"/>
-          </a:effectRef>
-          <a:fontRef idx="minor">
-            <a:schemeClr val="tx1"/>
-          </a:fontRef>
-        </p:style>
-      </p:cxnSp>
-      <p:sp>
-        <p:nvSpPr>
-          <p:cNvPr id="76" name="Oval 75">
-            <a:extLst>
-              <a:ext uri="{FF2B5EF4-FFF2-40B4-BE49-F238E27FC236}">
-                <a16:creationId xmlns:a16="http://schemas.microsoft.com/office/drawing/2014/main" id="{AD9B8ACE-4E6B-8F6F-45A3-2816550B8966}"/>
-              </a:ext>
-            </a:extLst>
-          </p:cNvPr>
-          <p:cNvSpPr/>
-          <p:nvPr/>
-        </p:nvSpPr>
-        <p:spPr>
-          <a:xfrm>
-            <a:off x="4780952" y="3797639"/>
-            <a:ext cx="388452" cy="369330"/>
-          </a:xfrm>
-          <a:prstGeom prst="ellipse">
-            <a:avLst/>
-          </a:prstGeom>
-          <a:noFill/>
-          <a:ln>
-            <a:solidFill>
-              <a:schemeClr val="tx1"/>
-            </a:solidFill>
-          </a:ln>
-        </p:spPr>
-        <p:style>
-          <a:lnRef idx="2">
-            <a:schemeClr val="accent1">
-              <a:shade val="50000"/>
-            </a:schemeClr>
-          </a:lnRef>
-          <a:fillRef idx="1">
-            <a:schemeClr val="accent1"/>
-          </a:fillRef>
-          <a:effectRef idx="0">
-            <a:schemeClr val="accent1"/>
-          </a:effectRef>
-          <a:fontRef idx="minor">
-            <a:schemeClr val="lt1"/>
-          </a:fontRef>
-        </p:style>
-        <p:txBody>
-          <a:bodyPr rtlCol="0" anchor="ctr"/>
-          <a:lstStyle/>
-          <a:p>
-            <a:pPr algn="ctr"/>
-            <a:endParaRPr lang="en-GB" dirty="0"/>
-          </a:p>
-        </p:txBody>
-      </p:sp>
-      <p:cxnSp>
-        <p:nvCxnSpPr>
-          <p:cNvPr id="77" name="Straight Connector 76">
-            <a:extLst>
-              <a:ext uri="{FF2B5EF4-FFF2-40B4-BE49-F238E27FC236}">
-                <a16:creationId xmlns:a16="http://schemas.microsoft.com/office/drawing/2014/main" id="{C143756B-29C3-4957-44B1-D90E58C1674E}"/>
-              </a:ext>
-            </a:extLst>
-          </p:cNvPr>
-          <p:cNvCxnSpPr>
-            <a:stCxn id="76" idx="1"/>
-            <a:endCxn id="76" idx="5"/>
-          </p:cNvCxnSpPr>
-          <p:nvPr/>
-        </p:nvCxnSpPr>
-        <p:spPr>
-          <a:xfrm>
-            <a:off x="4837839" y="3851726"/>
-            <a:ext cx="274678" cy="261156"/>
-          </a:xfrm>
-          <a:prstGeom prst="line">
-            <a:avLst/>
-          </a:prstGeom>
-          <a:ln>
-            <a:solidFill>
-              <a:schemeClr val="tx1"/>
-            </a:solidFill>
-          </a:ln>
-        </p:spPr>
-        <p:style>
-          <a:lnRef idx="1">
-            <a:schemeClr val="accent1"/>
-          </a:lnRef>
-          <a:fillRef idx="0">
-            <a:schemeClr val="accent1"/>
-          </a:fillRef>
-          <a:effectRef idx="0">
-            <a:schemeClr val="accent1"/>
-          </a:effectRef>
-          <a:fontRef idx="minor">
-            <a:schemeClr val="tx1"/>
-          </a:fontRef>
-        </p:style>
-      </p:cxnSp>
-      <p:cxnSp>
-        <p:nvCxnSpPr>
-          <p:cNvPr id="78" name="Straight Connector 77">
-            <a:extLst>
-              <a:ext uri="{FF2B5EF4-FFF2-40B4-BE49-F238E27FC236}">
-                <a16:creationId xmlns:a16="http://schemas.microsoft.com/office/drawing/2014/main" id="{D4DB9B87-9ED0-2673-679B-7F56385667B2}"/>
-              </a:ext>
-            </a:extLst>
-          </p:cNvPr>
-          <p:cNvCxnSpPr>
-            <a:stCxn id="76" idx="3"/>
-            <a:endCxn id="76" idx="7"/>
-          </p:cNvCxnSpPr>
-          <p:nvPr/>
-        </p:nvCxnSpPr>
-        <p:spPr>
-          <a:xfrm flipV="1">
-            <a:off x="4837839" y="3851726"/>
-            <a:ext cx="274678" cy="261156"/>
-          </a:xfrm>
-          <a:prstGeom prst="line">
-            <a:avLst/>
-          </a:prstGeom>
-          <a:ln>
-            <a:solidFill>
-              <a:schemeClr val="tx1"/>
-            </a:solidFill>
-          </a:ln>
-        </p:spPr>
-        <p:style>
-          <a:lnRef idx="1">
-            <a:schemeClr val="accent1"/>
-          </a:lnRef>
-          <a:fillRef idx="0">
-            <a:schemeClr val="accent1"/>
-          </a:fillRef>
-          <a:effectRef idx="0">
-            <a:schemeClr val="accent1"/>
-          </a:effectRef>
-          <a:fontRef idx="minor">
-            <a:schemeClr val="tx1"/>
-          </a:fontRef>
-        </p:style>
-      </p:cxnSp>
-      <p:cxnSp>
-        <p:nvCxnSpPr>
-          <p:cNvPr id="79" name="Gerade Verbindung mit Pfeil 1">
-            <a:extLst>
-              <a:ext uri="{FF2B5EF4-FFF2-40B4-BE49-F238E27FC236}">
-                <a16:creationId xmlns:a16="http://schemas.microsoft.com/office/drawing/2014/main" id="{C38B4B24-2416-42F0-B8C4-6EACDE4D9DF8}"/>
+          <p:cNvPr id="14" name="Gerade Verbindung mit Pfeil 7">
+            <a:extLst>
+              <a:ext uri="{FF2B5EF4-FFF2-40B4-BE49-F238E27FC236}">
+                <a16:creationId xmlns:a16="http://schemas.microsoft.com/office/drawing/2014/main" id="{2C838FB3-EF4E-888F-2DDF-B9CF48DC54AB}"/>
               </a:ext>
             </a:extLst>
           </p:cNvPr>
@@ -6134,9 +6319,9 @@
           <p:nvPr/>
         </p:nvCxnSpPr>
         <p:spPr>
-          <a:xfrm>
-            <a:off x="2374571" y="3978584"/>
-            <a:ext cx="2577596" cy="5063"/>
+          <a:xfrm flipV="1">
+            <a:off x="3984701" y="1329267"/>
+            <a:ext cx="0" cy="1371850"/>
           </a:xfrm>
           <a:prstGeom prst="straightConnector1">
             <a:avLst/>
@@ -6164,243 +6349,6 @@
           </a:fontRef>
         </p:style>
       </p:cxnSp>
-      <p:sp>
-        <p:nvSpPr>
-          <p:cNvPr id="83" name="Textfeld 25">
-            <a:extLst>
-              <a:ext uri="{FF2B5EF4-FFF2-40B4-BE49-F238E27FC236}">
-                <a16:creationId xmlns:a16="http://schemas.microsoft.com/office/drawing/2014/main" id="{0A625F1F-569F-6347-6745-47AE2B9DEF10}"/>
-              </a:ext>
-            </a:extLst>
-          </p:cNvPr>
-          <p:cNvSpPr txBox="1"/>
-          <p:nvPr/>
-        </p:nvSpPr>
-        <p:spPr>
-          <a:xfrm>
-            <a:off x="3179701" y="4024914"/>
-            <a:ext cx="1367278" cy="369332"/>
-          </a:xfrm>
-          <a:prstGeom prst="rect">
-            <a:avLst/>
-          </a:prstGeom>
-          <a:noFill/>
-        </p:spPr>
-        <p:txBody>
-          <a:bodyPr wrap="square" rtlCol="0">
-            <a:spAutoFit/>
-          </a:bodyPr>
-          <a:lstStyle/>
-          <a:p>
-            <a:pPr marL="0" marR="0" lvl="0" indent="0" algn="l" defTabSz="914400" rtl="0" eaLnBrk="1" fontAlgn="auto" latinLnBrk="0" hangingPunct="1">
-              <a:lnSpc>
-                <a:spcPct val="100000"/>
-              </a:lnSpc>
-              <a:spcBef>
-                <a:spcPts val="0"/>
-              </a:spcBef>
-              <a:spcAft>
-                <a:spcPts val="0"/>
-              </a:spcAft>
-              <a:buClrTx/>
-              <a:buSzTx/>
-              <a:buFontTx/>
-              <a:buNone/>
-              <a:tabLst/>
-              <a:defRPr/>
-            </a:pPr>
-            <a:r>
-              <a:rPr kumimoji="0" lang="de-DE" sz="1800" b="0" i="0" u="none" strike="noStrike" kern="1200" cap="none" spc="0" normalizeH="0" baseline="0" noProof="0" dirty="0">
-                <a:ln>
-                  <a:noFill/>
-                </a:ln>
-                <a:solidFill>
-                  <a:prstClr val="black"/>
-                </a:solidFill>
-                <a:effectLst/>
-                <a:uLnTx/>
-                <a:uFillTx/>
-                <a:latin typeface="Calibri" panose="020F0502020204030204"/>
-                <a:ea typeface="+mn-ea"/>
-                <a:cs typeface="+mn-cs"/>
-              </a:rPr>
-              <a:t>Ca. </a:t>
-            </a:r>
-            <a:r>
-              <a:rPr lang="de-DE" dirty="0">
-                <a:solidFill>
-                  <a:prstClr val="black"/>
-                </a:solidFill>
-                <a:latin typeface="Calibri" panose="020F0502020204030204"/>
-              </a:rPr>
-              <a:t>38.7</a:t>
-            </a:r>
-            <a:r>
-              <a:rPr kumimoji="0" lang="de-DE" sz="1800" b="0" i="0" u="none" strike="noStrike" kern="1200" cap="none" spc="0" normalizeH="0" baseline="0" noProof="0" dirty="0">
-                <a:ln>
-                  <a:noFill/>
-                </a:ln>
-                <a:solidFill>
-                  <a:prstClr val="black"/>
-                </a:solidFill>
-                <a:effectLst/>
-                <a:uLnTx/>
-                <a:uFillTx/>
-                <a:latin typeface="Calibri" panose="020F0502020204030204"/>
-                <a:ea typeface="+mn-ea"/>
-                <a:cs typeface="+mn-cs"/>
-              </a:rPr>
-              <a:t> mm</a:t>
-            </a:r>
-          </a:p>
-        </p:txBody>
-      </p:sp>
-      <p:cxnSp>
-        <p:nvCxnSpPr>
-          <p:cNvPr id="84" name="Gerade Verbindung mit Pfeil 7">
-            <a:extLst>
-              <a:ext uri="{FF2B5EF4-FFF2-40B4-BE49-F238E27FC236}">
-                <a16:creationId xmlns:a16="http://schemas.microsoft.com/office/drawing/2014/main" id="{6779554B-F03F-6430-B4A4-AE19C4CB3D59}"/>
-              </a:ext>
-            </a:extLst>
-          </p:cNvPr>
-          <p:cNvCxnSpPr>
-            <a:cxnSpLocks/>
-          </p:cNvCxnSpPr>
-          <p:nvPr/>
-        </p:nvCxnSpPr>
-        <p:spPr>
-          <a:xfrm flipV="1">
-            <a:off x="5318449" y="2770286"/>
-            <a:ext cx="0" cy="1178949"/>
-          </a:xfrm>
-          <a:prstGeom prst="straightConnector1">
-            <a:avLst/>
-          </a:prstGeom>
-          <a:ln>
-            <a:solidFill>
-              <a:schemeClr val="tx1"/>
-            </a:solidFill>
-            <a:headEnd type="triangle"/>
-            <a:tailEnd type="triangle"/>
-          </a:ln>
-        </p:spPr>
-        <p:style>
-          <a:lnRef idx="1">
-            <a:schemeClr val="accent1"/>
-          </a:lnRef>
-          <a:fillRef idx="0">
-            <a:schemeClr val="accent1"/>
-          </a:fillRef>
-          <a:effectRef idx="0">
-            <a:schemeClr val="accent1"/>
-          </a:effectRef>
-          <a:fontRef idx="minor">
-            <a:schemeClr val="tx1"/>
-          </a:fontRef>
-        </p:style>
-      </p:cxnSp>
-      <p:sp>
-        <p:nvSpPr>
-          <p:cNvPr id="85" name="Textfeld 25">
-            <a:extLst>
-              <a:ext uri="{FF2B5EF4-FFF2-40B4-BE49-F238E27FC236}">
-                <a16:creationId xmlns:a16="http://schemas.microsoft.com/office/drawing/2014/main" id="{76BE0EAB-65F7-C720-DF48-9A726E02041F}"/>
-              </a:ext>
-            </a:extLst>
-          </p:cNvPr>
-          <p:cNvSpPr txBox="1"/>
-          <p:nvPr/>
-        </p:nvSpPr>
-        <p:spPr>
-          <a:xfrm rot="16200000">
-            <a:off x="4899740" y="3110279"/>
-            <a:ext cx="1367278" cy="369332"/>
-          </a:xfrm>
-          <a:prstGeom prst="rect">
-            <a:avLst/>
-          </a:prstGeom>
-          <a:noFill/>
-        </p:spPr>
-        <p:txBody>
-          <a:bodyPr wrap="square" rtlCol="0">
-            <a:spAutoFit/>
-          </a:bodyPr>
-          <a:lstStyle/>
-          <a:p>
-            <a:pPr marL="0" marR="0" lvl="0" indent="0" algn="l" defTabSz="914400" rtl="0" eaLnBrk="1" fontAlgn="auto" latinLnBrk="0" hangingPunct="1">
-              <a:lnSpc>
-                <a:spcPct val="100000"/>
-              </a:lnSpc>
-              <a:spcBef>
-                <a:spcPts val="0"/>
-              </a:spcBef>
-              <a:spcAft>
-                <a:spcPts val="0"/>
-              </a:spcAft>
-              <a:buClrTx/>
-              <a:buSzTx/>
-              <a:buFontTx/>
-              <a:buNone/>
-              <a:tabLst/>
-              <a:defRPr/>
-            </a:pPr>
-            <a:r>
-              <a:rPr kumimoji="0" lang="de-DE" sz="1800" b="0" i="0" u="none" strike="noStrike" kern="1200" cap="none" spc="0" normalizeH="0" baseline="0" noProof="0" dirty="0">
-                <a:ln>
-                  <a:noFill/>
-                </a:ln>
-                <a:solidFill>
-                  <a:prstClr val="black"/>
-                </a:solidFill>
-                <a:effectLst/>
-                <a:uLnTx/>
-                <a:uFillTx/>
-                <a:latin typeface="Calibri" panose="020F0502020204030204"/>
-                <a:ea typeface="+mn-ea"/>
-                <a:cs typeface="+mn-cs"/>
-              </a:rPr>
-              <a:t>Ca. 33.5 mm</a:t>
-            </a:r>
-          </a:p>
-        </p:txBody>
-      </p:sp>
-      <p:sp>
-        <p:nvSpPr>
-          <p:cNvPr id="3" name="TextBox 2">
-            <a:extLst>
-              <a:ext uri="{FF2B5EF4-FFF2-40B4-BE49-F238E27FC236}">
-                <a16:creationId xmlns:a16="http://schemas.microsoft.com/office/drawing/2014/main" id="{954C7D5E-2207-47CF-B55D-A56E1F5C694E}"/>
-              </a:ext>
-            </a:extLst>
-          </p:cNvPr>
-          <p:cNvSpPr txBox="1"/>
-          <p:nvPr/>
-        </p:nvSpPr>
-        <p:spPr>
-          <a:xfrm>
-            <a:off x="684848" y="367282"/>
-            <a:ext cx="3072316" cy="461665"/>
-          </a:xfrm>
-          <a:prstGeom prst="rect">
-            <a:avLst/>
-          </a:prstGeom>
-          <a:noFill/>
-        </p:spPr>
-        <p:txBody>
-          <a:bodyPr wrap="none" rtlCol="0">
-            <a:spAutoFit/>
-          </a:bodyPr>
-          <a:lstStyle/>
-          <a:p>
-            <a:r>
-              <a:rPr lang="de-DE" sz="2400" b="1" dirty="0"/>
-              <a:t>Kühlkörper Bohrungen</a:t>
-            </a:r>
-            <a:endParaRPr lang="en-GB" sz="2400" b="1" dirty="0"/>
-          </a:p>
-        </p:txBody>
-      </p:sp>
     </p:spTree>
     <p:extLst>
       <p:ext uri="{BB962C8B-B14F-4D97-AF65-F5344CB8AC3E}">

</xml_diff>